<commit_message>
Kleisthenes: Wiederholung als Fehler-Übersicht zu Herrschaftsformen und Protagonisten (Folien 3–4, Handreichung)
Co-Authored-By: Claude Opus 5.5 <noreply@anthropic.com>
Claude-Session: https://claude.ai/code/session_013iN4Tiarea1J9YUJHZ9iqC
</commit_message>
<xml_diff>
--- a/Geschichte_11/Stunde_Kleisthenes/Folien_Kleisthenes.pptx
+++ b/Geschichte_11/Stunde_Kleisthenes/Folien_Kleisthenes.pptx
@@ -514,7 +514,7 @@
           <a:p>
             <a:r>
               <a:rPr lang="en-US" dirty="0"/>
-              <a:t>Titelfolie. Seitentafel vorbereitet: Ziel und Ablauf (Folie 2), daneben das leere Peisistratos-Gerüst (Skizze in der Handreichung).</a:t>
+              <a:t>Titelfolie. Seitentafel vorbereitet: Ziel und Ablauf (Folie 2).</a:t>
             </a:r>
             <a:endParaRPr lang="en-US" dirty="0"/>
           </a:p>
@@ -1042,7 +1042,7 @@
           <a:p>
             <a:r>
               <a:rPr lang="en-US" dirty="0"/>
-              <a:t>2–7 Min. Direkt: Wiederholung allein (2) – Partnercheck (1) – Stichproben bei 4 Schülern (2), du trägst ein. Warum: Der Abruf aus dem Gedächtnis fehlte letzte Stunde; die Phylen-Idee baut darauf auf (Peisistratos schwächte den Adel nur teilweise).</a:t>
+              <a:t>2–7 Min. Direkt: Vorwissen aktivieren über einen Fehlertext. Allein (2), Partnercheck (1), Stichproben bei 4–6 Schülern unterschiedlichen Niveaus (2). Buch und Hefter zu – nur das Heft für die Berichtigung. Die Fehler: Recht beim Adel; Schuldknechtschaft bleibt bei Drakon; Solon ohne Landverteilung; Rechte nach Besitz, Theten kein Archont; Peisistratos mit Söldnern; Verfassung bleibt.</a:t>
             </a:r>
             <a:endParaRPr lang="en-US" dirty="0"/>
           </a:p>
@@ -1130,7 +1130,7 @@
           <a:p>
             <a:r>
               <a:rPr lang="en-US" dirty="0"/>
-              <a:t>7–9 Min. Die offene Leitfrage der letzten Stunde: zwei Schüler antworten in einem Satz, dann die Folie. Das „Aber“ ist die Gelenkstelle zur heutigen Stunde.</a:t>
+              <a:t>7–9 Min. Lösung vergleichen, Fehler im Heft grün verbessern. Dann die offene Leitfrage der letzten Stunde: zwei Schüler antworten in einem Satz, danach der Satz unten auf der Folie. Das „Aber“ ist die Gelenkstelle zu heute.</a:t>
             </a:r>
             <a:endParaRPr lang="en-US" dirty="0"/>
           </a:p>
@@ -7956,7 +7956,7 @@
                 <a:ea typeface="Calibri" pitchFamily="34" charset="-122"/>
                 <a:cs typeface="Calibri" pitchFamily="34" charset="-120"/>
               </a:rPr>
-              <a:t>Wiederholung: Peisistratos – und was danach geschah</a:t>
+              <a:t>Wiederholung: Wer regierte Athen bisher? Fehler finden</a:t>
             </a:r>
             <a:endParaRPr lang="en-US" sz="1500" dirty="0"/>
           </a:p>
@@ -8696,7 +8696,7 @@
                 <a:ea typeface="Calibri" pitchFamily="34" charset="-122"/>
                 <a:cs typeface="Calibri" pitchFamily="34" charset="-120"/>
               </a:rPr>
-              <a:t>WIEDERHOLUNG · ALLEIN, DANN ZU ZWEIT</a:t>
+              <a:t>WIEDERHOLUNG · ALLEIN, DANN ZU ZWEIT · HEFT</a:t>
             </a:r>
             <a:endParaRPr lang="en-US" sz="1100" dirty="0"/>
           </a:p>
@@ -8735,7 +8735,7 @@
                 <a:ea typeface="Cambria" pitchFamily="34" charset="-122"/>
                 <a:cs typeface="Cambria" pitchFamily="34" charset="-120"/>
               </a:rPr>
-              <a:t>Was wisst ihr noch über Peisistratos?</a:t>
+              <a:t>Hier stimmt etwas nicht!</a:t>
             </a:r>
             <a:endParaRPr lang="en-US" sz="2600" dirty="0"/>
           </a:p>
@@ -8786,18 +8786,1078 @@
       </p:sp>
       <p:sp>
         <p:nvSpPr>
-          <p:cNvPr id="11" name="Shape 9"/>
-          <p:cNvSpPr/>
-          <p:nvPr/>
-        </p:nvSpPr>
-        <p:spPr>
-          <a:xfrm>
-            <a:off x="457200" y="1234440"/>
-            <a:ext cx="8229600" cy="457200"/>
+          <p:cNvPr id="11" name="Text 9"/>
+          <p:cNvSpPr txBox="1"/>
+          <p:nvPr/>
+        </p:nvSpPr>
+        <p:spPr>
+          <a:xfrm>
+            <a:off x="457200" y="1097280"/>
+            <a:ext cx="914400" cy="274320"/>
           </a:xfrm>
           <a:prstGeom prst="roundRect">
             <a:avLst>
-              <a:gd name="adj" fmla="val 16000"/>
+              <a:gd name="adj" fmla="val 26667"/>
+            </a:avLst>
+          </a:prstGeom>
+          <a:solidFill>
+            <a:srgbClr val="2B2318"/>
+          </a:solidFill>
+          <a:ln/>
+        </p:spPr>
+        <p:txBody>
+          <a:bodyPr wrap="square" lIns="0" tIns="0" rIns="0" bIns="0" rtlCol="0" anchor="ctr"/>
+          <a:lstStyle/>
+          <a:p>
+            <a:pPr algn="ctr" indent="0" marL="0">
+              <a:buNone/>
+            </a:pPr>
+            <a:r>
+              <a:rPr lang="en-US" sz="1150" b="1" dirty="0">
+                <a:solidFill>
+                  <a:srgbClr val="FFFFFF"/>
+                </a:solidFill>
+                <a:latin typeface="Calibri" pitchFamily="34" charset="0"/>
+                <a:ea typeface="Calibri" pitchFamily="34" charset="-122"/>
+                <a:cs typeface="Calibri" pitchFamily="34" charset="-120"/>
+              </a:rPr>
+              <a:t>Zeit</a:t>
+            </a:r>
+            <a:endParaRPr lang="en-US" sz="1150" dirty="0"/>
+          </a:p>
+        </p:txBody>
+      </p:sp>
+      <p:sp>
+        <p:nvSpPr>
+          <p:cNvPr id="12" name="Text 10"/>
+          <p:cNvSpPr txBox="1"/>
+          <p:nvPr/>
+        </p:nvSpPr>
+        <p:spPr>
+          <a:xfrm>
+            <a:off x="1417320" y="1097280"/>
+            <a:ext cx="1234440" cy="274320"/>
+          </a:xfrm>
+          <a:prstGeom prst="roundRect">
+            <a:avLst>
+              <a:gd name="adj" fmla="val 26667"/>
+            </a:avLst>
+          </a:prstGeom>
+          <a:solidFill>
+            <a:srgbClr val="2B2318"/>
+          </a:solidFill>
+          <a:ln/>
+        </p:spPr>
+        <p:txBody>
+          <a:bodyPr wrap="square" lIns="0" tIns="0" rIns="0" bIns="0" rtlCol="0" anchor="ctr"/>
+          <a:lstStyle/>
+          <a:p>
+            <a:pPr algn="ctr" indent="0" marL="0">
+              <a:buNone/>
+            </a:pPr>
+            <a:r>
+              <a:rPr lang="en-US" sz="1150" b="1" dirty="0">
+                <a:solidFill>
+                  <a:srgbClr val="FFFFFF"/>
+                </a:solidFill>
+                <a:latin typeface="Calibri" pitchFamily="34" charset="0"/>
+                <a:ea typeface="Calibri" pitchFamily="34" charset="-122"/>
+                <a:cs typeface="Calibri" pitchFamily="34" charset="-120"/>
+              </a:rPr>
+              <a:t>Herrschaftsform</a:t>
+            </a:r>
+            <a:endParaRPr lang="en-US" sz="1150" dirty="0"/>
+          </a:p>
+        </p:txBody>
+      </p:sp>
+      <p:sp>
+        <p:nvSpPr>
+          <p:cNvPr id="13" name="Text 11"/>
+          <p:cNvSpPr txBox="1"/>
+          <p:nvPr/>
+        </p:nvSpPr>
+        <p:spPr>
+          <a:xfrm>
+            <a:off x="2697480" y="1097280"/>
+            <a:ext cx="1325880" cy="274320"/>
+          </a:xfrm>
+          <a:prstGeom prst="roundRect">
+            <a:avLst>
+              <a:gd name="adj" fmla="val 26667"/>
+            </a:avLst>
+          </a:prstGeom>
+          <a:solidFill>
+            <a:srgbClr val="2B2318"/>
+          </a:solidFill>
+          <a:ln/>
+        </p:spPr>
+        <p:txBody>
+          <a:bodyPr wrap="square" lIns="0" tIns="0" rIns="0" bIns="0" rtlCol="0" anchor="ctr"/>
+          <a:lstStyle/>
+          <a:p>
+            <a:pPr algn="ctr" indent="0" marL="0">
+              <a:buNone/>
+            </a:pPr>
+            <a:r>
+              <a:rPr lang="en-US" sz="1150" b="1" dirty="0">
+                <a:solidFill>
+                  <a:srgbClr val="FFFFFF"/>
+                </a:solidFill>
+                <a:latin typeface="Calibri" pitchFamily="34" charset="0"/>
+                <a:ea typeface="Calibri" pitchFamily="34" charset="-122"/>
+                <a:cs typeface="Calibri" pitchFamily="34" charset="-120"/>
+              </a:rPr>
+              <a:t>Protagonist</a:t>
+            </a:r>
+            <a:endParaRPr lang="en-US" sz="1150" dirty="0"/>
+          </a:p>
+        </p:txBody>
+      </p:sp>
+      <p:sp>
+        <p:nvSpPr>
+          <p:cNvPr id="14" name="Text 12"/>
+          <p:cNvSpPr txBox="1"/>
+          <p:nvPr/>
+        </p:nvSpPr>
+        <p:spPr>
+          <a:xfrm>
+            <a:off x="4069080" y="1097280"/>
+            <a:ext cx="4617720" cy="274320"/>
+          </a:xfrm>
+          <a:prstGeom prst="roundRect">
+            <a:avLst>
+              <a:gd name="adj" fmla="val 26667"/>
+            </a:avLst>
+          </a:prstGeom>
+          <a:solidFill>
+            <a:srgbClr val="2B2318"/>
+          </a:solidFill>
+          <a:ln/>
+        </p:spPr>
+        <p:txBody>
+          <a:bodyPr wrap="square" lIns="0" tIns="0" rIns="0" bIns="0" rtlCol="0" anchor="ctr"/>
+          <a:lstStyle/>
+          <a:p>
+            <a:pPr algn="ctr" indent="0" marL="0">
+              <a:buNone/>
+            </a:pPr>
+            <a:r>
+              <a:rPr lang="en-US" sz="1150" b="1" dirty="0">
+                <a:solidFill>
+                  <a:srgbClr val="FFFFFF"/>
+                </a:solidFill>
+                <a:latin typeface="Calibri" pitchFamily="34" charset="0"/>
+                <a:ea typeface="Calibri" pitchFamily="34" charset="-122"/>
+                <a:cs typeface="Calibri" pitchFamily="34" charset="-120"/>
+              </a:rPr>
+              <a:t>Was geschah?</a:t>
+            </a:r>
+            <a:endParaRPr lang="en-US" sz="1150" dirty="0"/>
+          </a:p>
+        </p:txBody>
+      </p:sp>
+      <p:sp>
+        <p:nvSpPr>
+          <p:cNvPr id="15" name="Shape 13"/>
+          <p:cNvSpPr/>
+          <p:nvPr/>
+        </p:nvSpPr>
+        <p:spPr>
+          <a:xfrm>
+            <a:off x="457200" y="1426464"/>
+            <a:ext cx="8229600" cy="694944"/>
+          </a:xfrm>
+          <a:prstGeom prst="roundRect">
+            <a:avLst>
+              <a:gd name="adj" fmla="val 10526"/>
+            </a:avLst>
+          </a:prstGeom>
+          <a:solidFill>
+            <a:srgbClr val="FBF8F2"/>
+          </a:solidFill>
+          <a:ln w="12700">
+            <a:solidFill>
+              <a:srgbClr val="FBF8F2"/>
+            </a:solidFill>
+            <a:prstDash val="solid"/>
+          </a:ln>
+        </p:spPr>
+      </p:sp>
+      <p:sp>
+        <p:nvSpPr>
+          <p:cNvPr id="16" name="Text 14"/>
+          <p:cNvSpPr txBox="1"/>
+          <p:nvPr/>
+        </p:nvSpPr>
+        <p:spPr>
+          <a:xfrm>
+            <a:off x="502920" y="1426464"/>
+            <a:ext cx="914400" cy="694944"/>
+          </a:xfrm>
+          <a:prstGeom prst="rect">
+            <a:avLst/>
+          </a:prstGeom>
+          <a:noFill/>
+          <a:ln/>
+        </p:spPr>
+        <p:txBody>
+          <a:bodyPr wrap="square" lIns="0" tIns="0" rIns="0" bIns="0" rtlCol="0" anchor="ctr"/>
+          <a:lstStyle/>
+          <a:p>
+            <a:pPr indent="0" marL="0">
+              <a:buNone/>
+            </a:pPr>
+            <a:r>
+              <a:rPr lang="en-US" sz="1200" b="1" dirty="0">
+                <a:solidFill>
+                  <a:srgbClr val="2B2318"/>
+                </a:solidFill>
+                <a:latin typeface="Calibri" pitchFamily="34" charset="0"/>
+                <a:ea typeface="Calibri" pitchFamily="34" charset="-122"/>
+                <a:cs typeface="Calibri" pitchFamily="34" charset="-120"/>
+              </a:rPr>
+              <a:t>vor 600</a:t>
+            </a:r>
+            <a:endParaRPr lang="en-US" sz="1200" dirty="0"/>
+          </a:p>
+        </p:txBody>
+      </p:sp>
+      <p:sp>
+        <p:nvSpPr>
+          <p:cNvPr id="17" name="Text 15"/>
+          <p:cNvSpPr txBox="1"/>
+          <p:nvPr/>
+        </p:nvSpPr>
+        <p:spPr>
+          <a:xfrm>
+            <a:off x="1417320" y="1426464"/>
+            <a:ext cx="1234440" cy="694944"/>
+          </a:xfrm>
+          <a:prstGeom prst="rect">
+            <a:avLst/>
+          </a:prstGeom>
+          <a:noFill/>
+          <a:ln/>
+        </p:spPr>
+        <p:txBody>
+          <a:bodyPr wrap="square" lIns="0" tIns="0" rIns="0" bIns="0" rtlCol="0" anchor="ctr"/>
+          <a:lstStyle/>
+          <a:p>
+            <a:pPr indent="0" marL="0">
+              <a:buNone/>
+            </a:pPr>
+            <a:r>
+              <a:rPr lang="en-US" sz="1250" b="1" dirty="0">
+                <a:solidFill>
+                  <a:srgbClr val="AD4426"/>
+                </a:solidFill>
+                <a:latin typeface="Calibri" pitchFamily="34" charset="0"/>
+                <a:ea typeface="Calibri" pitchFamily="34" charset="-122"/>
+                <a:cs typeface="Calibri" pitchFamily="34" charset="-120"/>
+              </a:rPr>
+              <a:t>Aristokratie</a:t>
+            </a:r>
+            <a:endParaRPr lang="en-US" sz="1250" dirty="0"/>
+          </a:p>
+        </p:txBody>
+      </p:sp>
+      <p:sp>
+        <p:nvSpPr>
+          <p:cNvPr id="18" name="Text 16"/>
+          <p:cNvSpPr txBox="1"/>
+          <p:nvPr/>
+        </p:nvSpPr>
+        <p:spPr>
+          <a:xfrm>
+            <a:off x="2697480" y="1426464"/>
+            <a:ext cx="1325880" cy="694944"/>
+          </a:xfrm>
+          <a:prstGeom prst="rect">
+            <a:avLst/>
+          </a:prstGeom>
+          <a:noFill/>
+          <a:ln/>
+        </p:spPr>
+        <p:txBody>
+          <a:bodyPr wrap="square" lIns="0" tIns="0" rIns="0" bIns="0" rtlCol="0" anchor="ctr"/>
+          <a:lstStyle/>
+          <a:p>
+            <a:pPr indent="0" marL="0">
+              <a:buNone/>
+            </a:pPr>
+            <a:r>
+              <a:rPr lang="en-US" sz="1300" b="1" dirty="0">
+                <a:solidFill>
+                  <a:srgbClr val="2B2318"/>
+                </a:solidFill>
+                <a:latin typeface="Cambria" pitchFamily="34" charset="0"/>
+                <a:ea typeface="Cambria" pitchFamily="34" charset="-122"/>
+                <a:cs typeface="Cambria" pitchFamily="34" charset="-120"/>
+              </a:rPr>
+              <a:t>Adelsfamilien</a:t>
+            </a:r>
+            <a:endParaRPr lang="en-US" sz="1300" dirty="0"/>
+          </a:p>
+        </p:txBody>
+      </p:sp>
+      <p:sp>
+        <p:nvSpPr>
+          <p:cNvPr id="19" name="Text 17"/>
+          <p:cNvSpPr txBox="1"/>
+          <p:nvPr/>
+        </p:nvSpPr>
+        <p:spPr>
+          <a:xfrm>
+            <a:off x="4069080" y="1453896"/>
+            <a:ext cx="4617720" cy="329184"/>
+          </a:xfrm>
+          <a:prstGeom prst="rect">
+            <a:avLst/>
+          </a:prstGeom>
+          <a:noFill/>
+          <a:ln/>
+        </p:spPr>
+        <p:txBody>
+          <a:bodyPr wrap="square" lIns="0" tIns="0" rIns="0" bIns="0" rtlCol="0" anchor="ctr"/>
+          <a:lstStyle/>
+          <a:p>
+            <a:pPr indent="0" marL="0">
+              <a:buNone/>
+            </a:pPr>
+            <a:r>
+              <a:rPr lang="en-US" sz="1150" dirty="0">
+                <a:solidFill>
+                  <a:srgbClr val="2B2318"/>
+                </a:solidFill>
+                <a:latin typeface="Calibri" pitchFamily="34" charset="0"/>
+                <a:ea typeface="Calibri" pitchFamily="34" charset="-122"/>
+                <a:cs typeface="Calibri" pitchFamily="34" charset="-120"/>
+              </a:rPr>
+              <a:t>• Die Macht liegt bei wenigen Adelsfamilien; aus ihnen kommen die Archonten.</a:t>
+            </a:r>
+            <a:endParaRPr lang="en-US" sz="1150" dirty="0"/>
+          </a:p>
+        </p:txBody>
+      </p:sp>
+      <p:sp>
+        <p:nvSpPr>
+          <p:cNvPr id="20" name="Text 18"/>
+          <p:cNvSpPr txBox="1"/>
+          <p:nvPr/>
+        </p:nvSpPr>
+        <p:spPr>
+          <a:xfrm>
+            <a:off x="4069080" y="1783080"/>
+            <a:ext cx="4617720" cy="329184"/>
+          </a:xfrm>
+          <a:prstGeom prst="rect">
+            <a:avLst/>
+          </a:prstGeom>
+          <a:noFill/>
+          <a:ln/>
+        </p:spPr>
+        <p:txBody>
+          <a:bodyPr wrap="square" lIns="0" tIns="0" rIns="0" bIns="0" rtlCol="0" anchor="ctr"/>
+          <a:lstStyle/>
+          <a:p>
+            <a:pPr indent="0" marL="0">
+              <a:buNone/>
+            </a:pPr>
+            <a:r>
+              <a:rPr lang="en-US" sz="1150" dirty="0">
+                <a:solidFill>
+                  <a:srgbClr val="2B2318"/>
+                </a:solidFill>
+                <a:latin typeface="Calibri" pitchFamily="34" charset="0"/>
+                <a:ea typeface="Calibri" pitchFamily="34" charset="-122"/>
+                <a:cs typeface="Calibri" pitchFamily="34" charset="-120"/>
+              </a:rPr>
+              <a:t>• Recht sprechen gewählte Richter aus dem Volk.</a:t>
+            </a:r>
+            <a:endParaRPr lang="en-US" sz="1150" dirty="0"/>
+          </a:p>
+        </p:txBody>
+      </p:sp>
+      <p:sp>
+        <p:nvSpPr>
+          <p:cNvPr id="21" name="Shape 19"/>
+          <p:cNvSpPr/>
+          <p:nvPr/>
+        </p:nvSpPr>
+        <p:spPr>
+          <a:xfrm>
+            <a:off x="457200" y="2157984"/>
+            <a:ext cx="8229600" cy="694944"/>
+          </a:xfrm>
+          <a:prstGeom prst="roundRect">
+            <a:avLst>
+              <a:gd name="adj" fmla="val 10526"/>
+            </a:avLst>
+          </a:prstGeom>
+          <a:solidFill>
+            <a:srgbClr val="FFFFFF"/>
+          </a:solidFill>
+          <a:ln w="12700">
+            <a:solidFill>
+              <a:srgbClr val="FFFFFF"/>
+            </a:solidFill>
+            <a:prstDash val="solid"/>
+          </a:ln>
+        </p:spPr>
+      </p:sp>
+      <p:sp>
+        <p:nvSpPr>
+          <p:cNvPr id="22" name="Text 20"/>
+          <p:cNvSpPr txBox="1"/>
+          <p:nvPr/>
+        </p:nvSpPr>
+        <p:spPr>
+          <a:xfrm>
+            <a:off x="502920" y="2157984"/>
+            <a:ext cx="914400" cy="694944"/>
+          </a:xfrm>
+          <a:prstGeom prst="rect">
+            <a:avLst/>
+          </a:prstGeom>
+          <a:noFill/>
+          <a:ln/>
+        </p:spPr>
+        <p:txBody>
+          <a:bodyPr wrap="square" lIns="0" tIns="0" rIns="0" bIns="0" rtlCol="0" anchor="ctr"/>
+          <a:lstStyle/>
+          <a:p>
+            <a:pPr indent="0" marL="0">
+              <a:buNone/>
+            </a:pPr>
+            <a:r>
+              <a:rPr lang="en-US" sz="1200" b="1" dirty="0">
+                <a:solidFill>
+                  <a:srgbClr val="2B2318"/>
+                </a:solidFill>
+                <a:latin typeface="Calibri" pitchFamily="34" charset="0"/>
+                <a:ea typeface="Calibri" pitchFamily="34" charset="-122"/>
+                <a:cs typeface="Calibri" pitchFamily="34" charset="-120"/>
+              </a:rPr>
+              <a:t>624/621</a:t>
+            </a:r>
+            <a:endParaRPr lang="en-US" sz="1200" dirty="0"/>
+          </a:p>
+        </p:txBody>
+      </p:sp>
+      <p:sp>
+        <p:nvSpPr>
+          <p:cNvPr id="23" name="Text 21"/>
+          <p:cNvSpPr txBox="1"/>
+          <p:nvPr/>
+        </p:nvSpPr>
+        <p:spPr>
+          <a:xfrm>
+            <a:off x="1417320" y="2157984"/>
+            <a:ext cx="1234440" cy="694944"/>
+          </a:xfrm>
+          <a:prstGeom prst="rect">
+            <a:avLst/>
+          </a:prstGeom>
+          <a:noFill/>
+          <a:ln/>
+        </p:spPr>
+        <p:txBody>
+          <a:bodyPr wrap="square" lIns="0" tIns="0" rIns="0" bIns="0" rtlCol="0" anchor="ctr"/>
+          <a:lstStyle/>
+          <a:p>
+            <a:pPr indent="0" marL="0">
+              <a:buNone/>
+            </a:pPr>
+            <a:r>
+              <a:rPr lang="en-US" sz="1250" b="1" dirty="0">
+                <a:solidFill>
+                  <a:srgbClr val="AD4426"/>
+                </a:solidFill>
+                <a:latin typeface="Calibri" pitchFamily="34" charset="0"/>
+                <a:ea typeface="Calibri" pitchFamily="34" charset="-122"/>
+                <a:cs typeface="Calibri" pitchFamily="34" charset="-120"/>
+              </a:rPr>
+              <a:t>Aristokratie</a:t>
+            </a:r>
+            <a:endParaRPr lang="en-US" sz="1250" dirty="0"/>
+          </a:p>
+        </p:txBody>
+      </p:sp>
+      <p:sp>
+        <p:nvSpPr>
+          <p:cNvPr id="24" name="Text 22"/>
+          <p:cNvSpPr txBox="1"/>
+          <p:nvPr/>
+        </p:nvSpPr>
+        <p:spPr>
+          <a:xfrm>
+            <a:off x="2697480" y="2157984"/>
+            <a:ext cx="1325880" cy="694944"/>
+          </a:xfrm>
+          <a:prstGeom prst="rect">
+            <a:avLst/>
+          </a:prstGeom>
+          <a:noFill/>
+          <a:ln/>
+        </p:spPr>
+        <p:txBody>
+          <a:bodyPr wrap="square" lIns="0" tIns="0" rIns="0" bIns="0" rtlCol="0" anchor="ctr"/>
+          <a:lstStyle/>
+          <a:p>
+            <a:pPr indent="0" marL="0">
+              <a:buNone/>
+            </a:pPr>
+            <a:r>
+              <a:rPr lang="en-US" sz="1300" b="1" dirty="0">
+                <a:solidFill>
+                  <a:srgbClr val="2B2318"/>
+                </a:solidFill>
+                <a:latin typeface="Cambria" pitchFamily="34" charset="0"/>
+                <a:ea typeface="Cambria" pitchFamily="34" charset="-122"/>
+                <a:cs typeface="Cambria" pitchFamily="34" charset="-120"/>
+              </a:rPr>
+              <a:t>Drakon</a:t>
+            </a:r>
+            <a:endParaRPr lang="en-US" sz="1300" dirty="0"/>
+          </a:p>
+        </p:txBody>
+      </p:sp>
+      <p:sp>
+        <p:nvSpPr>
+          <p:cNvPr id="25" name="Text 23"/>
+          <p:cNvSpPr txBox="1"/>
+          <p:nvPr/>
+        </p:nvSpPr>
+        <p:spPr>
+          <a:xfrm>
+            <a:off x="4069080" y="2185416"/>
+            <a:ext cx="4617720" cy="329184"/>
+          </a:xfrm>
+          <a:prstGeom prst="rect">
+            <a:avLst/>
+          </a:prstGeom>
+          <a:noFill/>
+          <a:ln/>
+        </p:spPr>
+        <p:txBody>
+          <a:bodyPr wrap="square" lIns="0" tIns="0" rIns="0" bIns="0" rtlCol="0" anchor="ctr"/>
+          <a:lstStyle/>
+          <a:p>
+            <a:pPr indent="0" marL="0">
+              <a:buNone/>
+            </a:pPr>
+            <a:r>
+              <a:rPr lang="en-US" sz="1150" dirty="0">
+                <a:solidFill>
+                  <a:srgbClr val="2B2318"/>
+                </a:solidFill>
+                <a:latin typeface="Calibri" pitchFamily="34" charset="0"/>
+                <a:ea typeface="Calibri" pitchFamily="34" charset="-122"/>
+                <a:cs typeface="Calibri" pitchFamily="34" charset="-120"/>
+              </a:rPr>
+              <a:t>• Er schreibt das Recht erstmals auf; staatliche Richter ersetzen die Blutrache.</a:t>
+            </a:r>
+            <a:endParaRPr lang="en-US" sz="1150" dirty="0"/>
+          </a:p>
+        </p:txBody>
+      </p:sp>
+      <p:sp>
+        <p:nvSpPr>
+          <p:cNvPr id="26" name="Text 24"/>
+          <p:cNvSpPr txBox="1"/>
+          <p:nvPr/>
+        </p:nvSpPr>
+        <p:spPr>
+          <a:xfrm>
+            <a:off x="4069080" y="2514600"/>
+            <a:ext cx="4617720" cy="329184"/>
+          </a:xfrm>
+          <a:prstGeom prst="rect">
+            <a:avLst/>
+          </a:prstGeom>
+          <a:noFill/>
+          <a:ln/>
+        </p:spPr>
+        <p:txBody>
+          <a:bodyPr wrap="square" lIns="0" tIns="0" rIns="0" bIns="0" rtlCol="0" anchor="ctr"/>
+          <a:lstStyle/>
+          <a:p>
+            <a:pPr indent="0" marL="0">
+              <a:buNone/>
+            </a:pPr>
+            <a:r>
+              <a:rPr lang="en-US" sz="1150" dirty="0">
+                <a:solidFill>
+                  <a:srgbClr val="2B2318"/>
+                </a:solidFill>
+                <a:latin typeface="Calibri" pitchFamily="34" charset="0"/>
+                <a:ea typeface="Calibri" pitchFamily="34" charset="-122"/>
+                <a:cs typeface="Calibri" pitchFamily="34" charset="-120"/>
+              </a:rPr>
+              <a:t>• Er schafft die Schuldknechtschaft ab.</a:t>
+            </a:r>
+            <a:endParaRPr lang="en-US" sz="1150" dirty="0"/>
+          </a:p>
+        </p:txBody>
+      </p:sp>
+      <p:sp>
+        <p:nvSpPr>
+          <p:cNvPr id="27" name="Shape 25"/>
+          <p:cNvSpPr/>
+          <p:nvPr/>
+        </p:nvSpPr>
+        <p:spPr>
+          <a:xfrm>
+            <a:off x="457200" y="2889504"/>
+            <a:ext cx="8229600" cy="694944"/>
+          </a:xfrm>
+          <a:prstGeom prst="roundRect">
+            <a:avLst>
+              <a:gd name="adj" fmla="val 10526"/>
+            </a:avLst>
+          </a:prstGeom>
+          <a:solidFill>
+            <a:srgbClr val="FBF8F2"/>
+          </a:solidFill>
+          <a:ln w="12700">
+            <a:solidFill>
+              <a:srgbClr val="FBF8F2"/>
+            </a:solidFill>
+            <a:prstDash val="solid"/>
+          </a:ln>
+        </p:spPr>
+      </p:sp>
+      <p:sp>
+        <p:nvSpPr>
+          <p:cNvPr id="28" name="Text 26"/>
+          <p:cNvSpPr txBox="1"/>
+          <p:nvPr/>
+        </p:nvSpPr>
+        <p:spPr>
+          <a:xfrm>
+            <a:off x="502920" y="2889504"/>
+            <a:ext cx="914400" cy="694944"/>
+          </a:xfrm>
+          <a:prstGeom prst="rect">
+            <a:avLst/>
+          </a:prstGeom>
+          <a:noFill/>
+          <a:ln/>
+        </p:spPr>
+        <p:txBody>
+          <a:bodyPr wrap="square" lIns="0" tIns="0" rIns="0" bIns="0" rtlCol="0" anchor="ctr"/>
+          <a:lstStyle/>
+          <a:p>
+            <a:pPr indent="0" marL="0">
+              <a:buNone/>
+            </a:pPr>
+            <a:r>
+              <a:rPr lang="en-US" sz="1200" b="1" dirty="0">
+                <a:solidFill>
+                  <a:srgbClr val="2B2318"/>
+                </a:solidFill>
+                <a:latin typeface="Calibri" pitchFamily="34" charset="0"/>
+                <a:ea typeface="Calibri" pitchFamily="34" charset="-122"/>
+                <a:cs typeface="Calibri" pitchFamily="34" charset="-120"/>
+              </a:rPr>
+              <a:t>594/93</a:t>
+            </a:r>
+            <a:endParaRPr lang="en-US" sz="1200" dirty="0"/>
+          </a:p>
+        </p:txBody>
+      </p:sp>
+      <p:sp>
+        <p:nvSpPr>
+          <p:cNvPr id="29" name="Text 27"/>
+          <p:cNvSpPr txBox="1"/>
+          <p:nvPr/>
+        </p:nvSpPr>
+        <p:spPr>
+          <a:xfrm>
+            <a:off x="1417320" y="2889504"/>
+            <a:ext cx="1234440" cy="694944"/>
+          </a:xfrm>
+          <a:prstGeom prst="rect">
+            <a:avLst/>
+          </a:prstGeom>
+          <a:noFill/>
+          <a:ln/>
+        </p:spPr>
+        <p:txBody>
+          <a:bodyPr wrap="square" lIns="0" tIns="0" rIns="0" bIns="0" rtlCol="0" anchor="ctr"/>
+          <a:lstStyle/>
+          <a:p>
+            <a:pPr indent="0" marL="0">
+              <a:buNone/>
+            </a:pPr>
+            <a:r>
+              <a:rPr lang="en-US" sz="1250" b="1" dirty="0">
+                <a:solidFill>
+                  <a:srgbClr val="AD4426"/>
+                </a:solidFill>
+                <a:latin typeface="Calibri" pitchFamily="34" charset="0"/>
+                <a:ea typeface="Calibri" pitchFamily="34" charset="-122"/>
+                <a:cs typeface="Calibri" pitchFamily="34" charset="-120"/>
+              </a:rPr>
+              <a:t>Timokratie</a:t>
+            </a:r>
+            <a:endParaRPr lang="en-US" sz="1250" dirty="0"/>
+          </a:p>
+        </p:txBody>
+      </p:sp>
+      <p:sp>
+        <p:nvSpPr>
+          <p:cNvPr id="30" name="Text 28"/>
+          <p:cNvSpPr txBox="1"/>
+          <p:nvPr/>
+        </p:nvSpPr>
+        <p:spPr>
+          <a:xfrm>
+            <a:off x="2697480" y="2889504"/>
+            <a:ext cx="1325880" cy="694944"/>
+          </a:xfrm>
+          <a:prstGeom prst="rect">
+            <a:avLst/>
+          </a:prstGeom>
+          <a:noFill/>
+          <a:ln/>
+        </p:spPr>
+        <p:txBody>
+          <a:bodyPr wrap="square" lIns="0" tIns="0" rIns="0" bIns="0" rtlCol="0" anchor="ctr"/>
+          <a:lstStyle/>
+          <a:p>
+            <a:pPr indent="0" marL="0">
+              <a:buNone/>
+            </a:pPr>
+            <a:r>
+              <a:rPr lang="en-US" sz="1300" b="1" dirty="0">
+                <a:solidFill>
+                  <a:srgbClr val="2B2318"/>
+                </a:solidFill>
+                <a:latin typeface="Cambria" pitchFamily="34" charset="0"/>
+                <a:ea typeface="Cambria" pitchFamily="34" charset="-122"/>
+                <a:cs typeface="Cambria" pitchFamily="34" charset="-120"/>
+              </a:rPr>
+              <a:t>Solon</a:t>
+            </a:r>
+            <a:endParaRPr lang="en-US" sz="1300" dirty="0"/>
+          </a:p>
+        </p:txBody>
+      </p:sp>
+      <p:sp>
+        <p:nvSpPr>
+          <p:cNvPr id="31" name="Text 29"/>
+          <p:cNvSpPr txBox="1"/>
+          <p:nvPr/>
+        </p:nvSpPr>
+        <p:spPr>
+          <a:xfrm>
+            <a:off x="4069080" y="2916936"/>
+            <a:ext cx="4617720" cy="329184"/>
+          </a:xfrm>
+          <a:prstGeom prst="rect">
+            <a:avLst/>
+          </a:prstGeom>
+          <a:noFill/>
+          <a:ln/>
+        </p:spPr>
+        <p:txBody>
+          <a:bodyPr wrap="square" lIns="0" tIns="0" rIns="0" bIns="0" rtlCol="0" anchor="ctr"/>
+          <a:lstStyle/>
+          <a:p>
+            <a:pPr indent="0" marL="0">
+              <a:buNone/>
+            </a:pPr>
+            <a:r>
+              <a:rPr lang="en-US" sz="1150" dirty="0">
+                <a:solidFill>
+                  <a:srgbClr val="2B2318"/>
+                </a:solidFill>
+                <a:latin typeface="Calibri" pitchFamily="34" charset="0"/>
+                <a:ea typeface="Calibri" pitchFamily="34" charset="-122"/>
+                <a:cs typeface="Calibri" pitchFamily="34" charset="-120"/>
+              </a:rPr>
+              <a:t>• Er streicht die Schulden und verteilt das Land der Großgrundbesitzer neu.</a:t>
+            </a:r>
+            <a:endParaRPr lang="en-US" sz="1150" dirty="0"/>
+          </a:p>
+        </p:txBody>
+      </p:sp>
+      <p:sp>
+        <p:nvSpPr>
+          <p:cNvPr id="32" name="Text 30"/>
+          <p:cNvSpPr txBox="1"/>
+          <p:nvPr/>
+        </p:nvSpPr>
+        <p:spPr>
+          <a:xfrm>
+            <a:off x="4069080" y="3246120"/>
+            <a:ext cx="4617720" cy="329184"/>
+          </a:xfrm>
+          <a:prstGeom prst="rect">
+            <a:avLst/>
+          </a:prstGeom>
+          <a:noFill/>
+          <a:ln/>
+        </p:spPr>
+        <p:txBody>
+          <a:bodyPr wrap="square" lIns="0" tIns="0" rIns="0" bIns="0" rtlCol="0" anchor="ctr"/>
+          <a:lstStyle/>
+          <a:p>
+            <a:pPr indent="0" marL="0">
+              <a:buNone/>
+            </a:pPr>
+            <a:r>
+              <a:rPr lang="en-US" sz="1150" dirty="0">
+                <a:solidFill>
+                  <a:srgbClr val="2B2318"/>
+                </a:solidFill>
+                <a:latin typeface="Calibri" pitchFamily="34" charset="0"/>
+                <a:ea typeface="Calibri" pitchFamily="34" charset="-122"/>
+                <a:cs typeface="Calibri" pitchFamily="34" charset="-120"/>
+              </a:rPr>
+              <a:t>• Die Rechte richten sich nach der Herkunft; auch Theten dürfen Archont werden.</a:t>
+            </a:r>
+            <a:endParaRPr lang="en-US" sz="1150" dirty="0"/>
+          </a:p>
+        </p:txBody>
+      </p:sp>
+      <p:sp>
+        <p:nvSpPr>
+          <p:cNvPr id="33" name="Shape 31"/>
+          <p:cNvSpPr/>
+          <p:nvPr/>
+        </p:nvSpPr>
+        <p:spPr>
+          <a:xfrm>
+            <a:off x="457200" y="3621024"/>
+            <a:ext cx="8229600" cy="694944"/>
+          </a:xfrm>
+          <a:prstGeom prst="roundRect">
+            <a:avLst>
+              <a:gd name="adj" fmla="val 10526"/>
+            </a:avLst>
+          </a:prstGeom>
+          <a:solidFill>
+            <a:srgbClr val="FFFFFF"/>
+          </a:solidFill>
+          <a:ln w="12700">
+            <a:solidFill>
+              <a:srgbClr val="FFFFFF"/>
+            </a:solidFill>
+            <a:prstDash val="solid"/>
+          </a:ln>
+        </p:spPr>
+      </p:sp>
+      <p:sp>
+        <p:nvSpPr>
+          <p:cNvPr id="34" name="Text 32"/>
+          <p:cNvSpPr txBox="1"/>
+          <p:nvPr/>
+        </p:nvSpPr>
+        <p:spPr>
+          <a:xfrm>
+            <a:off x="502920" y="3621024"/>
+            <a:ext cx="914400" cy="694944"/>
+          </a:xfrm>
+          <a:prstGeom prst="rect">
+            <a:avLst/>
+          </a:prstGeom>
+          <a:noFill/>
+          <a:ln/>
+        </p:spPr>
+        <p:txBody>
+          <a:bodyPr wrap="square" lIns="0" tIns="0" rIns="0" bIns="0" rtlCol="0" anchor="ctr"/>
+          <a:lstStyle/>
+          <a:p>
+            <a:pPr indent="0" marL="0">
+              <a:buNone/>
+            </a:pPr>
+            <a:r>
+              <a:rPr lang="en-US" sz="1200" b="1" dirty="0">
+                <a:solidFill>
+                  <a:srgbClr val="2B2318"/>
+                </a:solidFill>
+                <a:latin typeface="Calibri" pitchFamily="34" charset="0"/>
+                <a:ea typeface="Calibri" pitchFamily="34" charset="-122"/>
+                <a:cs typeface="Calibri" pitchFamily="34" charset="-120"/>
+              </a:rPr>
+              <a:t>546–528/27</a:t>
+            </a:r>
+            <a:endParaRPr lang="en-US" sz="1200" dirty="0"/>
+          </a:p>
+        </p:txBody>
+      </p:sp>
+      <p:sp>
+        <p:nvSpPr>
+          <p:cNvPr id="35" name="Text 33"/>
+          <p:cNvSpPr txBox="1"/>
+          <p:nvPr/>
+        </p:nvSpPr>
+        <p:spPr>
+          <a:xfrm>
+            <a:off x="1417320" y="3621024"/>
+            <a:ext cx="1234440" cy="694944"/>
+          </a:xfrm>
+          <a:prstGeom prst="rect">
+            <a:avLst/>
+          </a:prstGeom>
+          <a:noFill/>
+          <a:ln/>
+        </p:spPr>
+        <p:txBody>
+          <a:bodyPr wrap="square" lIns="0" tIns="0" rIns="0" bIns="0" rtlCol="0" anchor="ctr"/>
+          <a:lstStyle/>
+          <a:p>
+            <a:pPr indent="0" marL="0">
+              <a:buNone/>
+            </a:pPr>
+            <a:r>
+              <a:rPr lang="en-US" sz="1250" b="1" dirty="0">
+                <a:solidFill>
+                  <a:srgbClr val="AD4426"/>
+                </a:solidFill>
+                <a:latin typeface="Calibri" pitchFamily="34" charset="0"/>
+                <a:ea typeface="Calibri" pitchFamily="34" charset="-122"/>
+                <a:cs typeface="Calibri" pitchFamily="34" charset="-120"/>
+              </a:rPr>
+              <a:t>Tyrannis</a:t>
+            </a:r>
+            <a:endParaRPr lang="en-US" sz="1250" dirty="0"/>
+          </a:p>
+        </p:txBody>
+      </p:sp>
+      <p:sp>
+        <p:nvSpPr>
+          <p:cNvPr id="36" name="Text 34"/>
+          <p:cNvSpPr txBox="1"/>
+          <p:nvPr/>
+        </p:nvSpPr>
+        <p:spPr>
+          <a:xfrm>
+            <a:off x="2697480" y="3621024"/>
+            <a:ext cx="1325880" cy="694944"/>
+          </a:xfrm>
+          <a:prstGeom prst="rect">
+            <a:avLst/>
+          </a:prstGeom>
+          <a:noFill/>
+          <a:ln/>
+        </p:spPr>
+        <p:txBody>
+          <a:bodyPr wrap="square" lIns="0" tIns="0" rIns="0" bIns="0" rtlCol="0" anchor="ctr"/>
+          <a:lstStyle/>
+          <a:p>
+            <a:pPr indent="0" marL="0">
+              <a:buNone/>
+            </a:pPr>
+            <a:r>
+              <a:rPr lang="en-US" sz="1300" b="1" dirty="0">
+                <a:solidFill>
+                  <a:srgbClr val="2B2318"/>
+                </a:solidFill>
+                <a:latin typeface="Cambria" pitchFamily="34" charset="0"/>
+                <a:ea typeface="Cambria" pitchFamily="34" charset="-122"/>
+                <a:cs typeface="Cambria" pitchFamily="34" charset="-120"/>
+              </a:rPr>
+              <a:t>Peisistratos</a:t>
+            </a:r>
+            <a:endParaRPr lang="en-US" sz="1300" dirty="0"/>
+          </a:p>
+        </p:txBody>
+      </p:sp>
+      <p:sp>
+        <p:nvSpPr>
+          <p:cNvPr id="37" name="Text 35"/>
+          <p:cNvSpPr txBox="1"/>
+          <p:nvPr/>
+        </p:nvSpPr>
+        <p:spPr>
+          <a:xfrm>
+            <a:off x="4069080" y="3648456"/>
+            <a:ext cx="4617720" cy="329184"/>
+          </a:xfrm>
+          <a:prstGeom prst="rect">
+            <a:avLst/>
+          </a:prstGeom>
+          <a:noFill/>
+          <a:ln/>
+        </p:spPr>
+        <p:txBody>
+          <a:bodyPr wrap="square" lIns="0" tIns="0" rIns="0" bIns="0" rtlCol="0" anchor="ctr"/>
+          <a:lstStyle/>
+          <a:p>
+            <a:pPr indent="0" marL="0">
+              <a:buNone/>
+            </a:pPr>
+            <a:r>
+              <a:rPr lang="en-US" sz="1150" dirty="0">
+                <a:solidFill>
+                  <a:srgbClr val="2B2318"/>
+                </a:solidFill>
+                <a:latin typeface="Calibri" pitchFamily="34" charset="0"/>
+                <a:ea typeface="Calibri" pitchFamily="34" charset="-122"/>
+                <a:cs typeface="Calibri" pitchFamily="34" charset="-120"/>
+              </a:rPr>
+              <a:t>• Die Volksversammlung wählt ihn zum Alleinherrscher.</a:t>
+            </a:r>
+            <a:endParaRPr lang="en-US" sz="1150" dirty="0"/>
+          </a:p>
+        </p:txBody>
+      </p:sp>
+      <p:sp>
+        <p:nvSpPr>
+          <p:cNvPr id="38" name="Text 36"/>
+          <p:cNvSpPr txBox="1"/>
+          <p:nvPr/>
+        </p:nvSpPr>
+        <p:spPr>
+          <a:xfrm>
+            <a:off x="4069080" y="3977640"/>
+            <a:ext cx="4617720" cy="329184"/>
+          </a:xfrm>
+          <a:prstGeom prst="rect">
+            <a:avLst/>
+          </a:prstGeom>
+          <a:noFill/>
+          <a:ln/>
+        </p:spPr>
+        <p:txBody>
+          <a:bodyPr wrap="square" lIns="0" tIns="0" rIns="0" bIns="0" rtlCol="0" anchor="ctr"/>
+          <a:lstStyle/>
+          <a:p>
+            <a:pPr indent="0" marL="0">
+              <a:buNone/>
+            </a:pPr>
+            <a:r>
+              <a:rPr lang="en-US" sz="1150" dirty="0">
+                <a:solidFill>
+                  <a:srgbClr val="2B2318"/>
+                </a:solidFill>
+                <a:latin typeface="Calibri" pitchFamily="34" charset="0"/>
+                <a:ea typeface="Calibri" pitchFamily="34" charset="-122"/>
+                <a:cs typeface="Calibri" pitchFamily="34" charset="-120"/>
+              </a:rPr>
+              <a:t>• Er schafft Solons Verfassung ab, fördert aber Bauern und Handwerk.</a:t>
+            </a:r>
+            <a:endParaRPr lang="en-US" sz="1150" dirty="0"/>
+          </a:p>
+        </p:txBody>
+      </p:sp>
+      <p:sp>
+        <p:nvSpPr>
+          <p:cNvPr id="39" name="Shape 37"/>
+          <p:cNvSpPr/>
+          <p:nvPr/>
+        </p:nvSpPr>
+        <p:spPr>
+          <a:xfrm>
+            <a:off x="457200" y="4389120"/>
+            <a:ext cx="8229600" cy="329184"/>
+          </a:xfrm>
+          <a:prstGeom prst="roundRect">
+            <a:avLst>
+              <a:gd name="adj" fmla="val 22222"/>
             </a:avLst>
           </a:prstGeom>
           <a:solidFill>
@@ -8813,14 +9873,14 @@
       </p:sp>
       <p:sp>
         <p:nvSpPr>
-          <p:cNvPr id="12" name="Text 10"/>
-          <p:cNvSpPr txBox="1"/>
-          <p:nvPr/>
-        </p:nvSpPr>
-        <p:spPr>
-          <a:xfrm>
-            <a:off x="685800" y="1234440"/>
-            <a:ext cx="7772400" cy="457200"/>
+          <p:cNvPr id="40" name="Text 38"/>
+          <p:cNvSpPr txBox="1"/>
+          <p:nvPr/>
+        </p:nvSpPr>
+        <p:spPr>
+          <a:xfrm>
+            <a:off x="594360" y="4389120"/>
+            <a:ext cx="7955280" cy="329184"/>
           </a:xfrm>
           <a:prstGeom prst="rect">
             <a:avLst/>
@@ -8836,7 +9896,7 @@
               <a:buNone/>
             </a:pPr>
             <a:r>
-              <a:rPr lang="en-US" sz="1600" b="1" dirty="0">
+              <a:rPr lang="en-US" sz="1150" b="1" dirty="0">
                 <a:solidFill>
                   <a:srgbClr val="FFFFFF"/>
                 </a:solidFill>
@@ -8844,360 +9904,9 @@
                 <a:ea typeface="Calibri" pitchFamily="34" charset="-122"/>
                 <a:cs typeface="Calibri" pitchFamily="34" charset="-120"/>
               </a:rPr>
-              <a:t>Buch und Hefter bleiben zu.</a:t>
-            </a:r>
-            <a:endParaRPr lang="en-US" sz="1600" dirty="0"/>
-          </a:p>
-        </p:txBody>
-      </p:sp>
-      <p:sp>
-        <p:nvSpPr>
-          <p:cNvPr id="13" name="Text 11"/>
-          <p:cNvSpPr txBox="1"/>
-          <p:nvPr/>
-        </p:nvSpPr>
-        <p:spPr>
-          <a:xfrm>
-            <a:off x="457200" y="1920240"/>
-            <a:ext cx="365760" cy="365760"/>
-          </a:xfrm>
-          <a:prstGeom prst="ellipse">
-            <a:avLst/>
-          </a:prstGeom>
-          <a:solidFill>
-            <a:srgbClr val="AD4426"/>
-          </a:solidFill>
-          <a:ln/>
-        </p:spPr>
-        <p:txBody>
-          <a:bodyPr wrap="square" lIns="0" tIns="0" rIns="0" bIns="0" rtlCol="0" anchor="ctr"/>
-          <a:lstStyle/>
-          <a:p>
-            <a:pPr algn="ctr" indent="0" marL="0">
-              <a:buNone/>
-            </a:pPr>
-            <a:r>
-              <a:rPr lang="en-US" sz="1400" b="1" dirty="0">
-                <a:solidFill>
-                  <a:srgbClr val="FFFFFF"/>
-                </a:solidFill>
-                <a:latin typeface="Cambria" pitchFamily="34" charset="0"/>
-                <a:ea typeface="Cambria" pitchFamily="34" charset="-122"/>
-                <a:cs typeface="Cambria" pitchFamily="34" charset="-120"/>
-              </a:rPr>
-              <a:t>1</a:t>
-            </a:r>
-            <a:endParaRPr lang="en-US" sz="1400" dirty="0"/>
-          </a:p>
-        </p:txBody>
-      </p:sp>
-      <p:sp>
-        <p:nvSpPr>
-          <p:cNvPr id="14" name="Text 12"/>
-          <p:cNvSpPr txBox="1"/>
-          <p:nvPr/>
-        </p:nvSpPr>
-        <p:spPr>
-          <a:xfrm>
-            <a:off x="960120" y="1883664"/>
-            <a:ext cx="4343400" cy="740664"/>
-          </a:xfrm>
-          <a:prstGeom prst="rect">
-            <a:avLst/>
-          </a:prstGeom>
-          <a:noFill/>
-          <a:ln/>
-        </p:spPr>
-        <p:txBody>
-          <a:bodyPr wrap="square" lIns="0" tIns="0" rIns="0" bIns="0" rtlCol="0" anchor="ctr"/>
-          <a:lstStyle/>
-          <a:p>
-            <a:pPr indent="0" marL="0">
-              <a:buNone/>
-            </a:pPr>
-            <a:r>
-              <a:rPr lang="en-US" sz="1350" dirty="0">
-                <a:solidFill>
-                  <a:srgbClr val="2B2318"/>
-                </a:solidFill>
-                <a:latin typeface="Calibri" pitchFamily="34" charset="0"/>
-                <a:ea typeface="Calibri" pitchFamily="34" charset="-122"/>
-                <a:cs typeface="Calibri" pitchFamily="34" charset="-120"/>
-              </a:rPr>
-              <a:t>Schau dir das leere Gerüst an der Tafel an. Notiere im Heft zu jedem der vier Felder ein Stichwort: Wer profitiert, und wovon?</a:t>
-            </a:r>
-            <a:endParaRPr lang="en-US" sz="1350" dirty="0"/>
-          </a:p>
-        </p:txBody>
-      </p:sp>
-      <p:sp>
-        <p:nvSpPr>
-          <p:cNvPr id="15" name="Text 13"/>
-          <p:cNvSpPr txBox="1"/>
-          <p:nvPr/>
-        </p:nvSpPr>
-        <p:spPr>
-          <a:xfrm>
-            <a:off x="457200" y="2697480"/>
-            <a:ext cx="365760" cy="365760"/>
-          </a:xfrm>
-          <a:prstGeom prst="ellipse">
-            <a:avLst/>
-          </a:prstGeom>
-          <a:solidFill>
-            <a:srgbClr val="AD4426"/>
-          </a:solidFill>
-          <a:ln/>
-        </p:spPr>
-        <p:txBody>
-          <a:bodyPr wrap="square" lIns="0" tIns="0" rIns="0" bIns="0" rtlCol="0" anchor="ctr"/>
-          <a:lstStyle/>
-          <a:p>
-            <a:pPr algn="ctr" indent="0" marL="0">
-              <a:buNone/>
-            </a:pPr>
-            <a:r>
-              <a:rPr lang="en-US" sz="1400" b="1" dirty="0">
-                <a:solidFill>
-                  <a:srgbClr val="FFFFFF"/>
-                </a:solidFill>
-                <a:latin typeface="Cambria" pitchFamily="34" charset="0"/>
-                <a:ea typeface="Cambria" pitchFamily="34" charset="-122"/>
-                <a:cs typeface="Cambria" pitchFamily="34" charset="-120"/>
-              </a:rPr>
-              <a:t>2</a:t>
-            </a:r>
-            <a:endParaRPr lang="en-US" sz="1400" dirty="0"/>
-          </a:p>
-        </p:txBody>
-      </p:sp>
-      <p:sp>
-        <p:nvSpPr>
-          <p:cNvPr id="16" name="Text 14"/>
-          <p:cNvSpPr txBox="1"/>
-          <p:nvPr/>
-        </p:nvSpPr>
-        <p:spPr>
-          <a:xfrm>
-            <a:off x="960120" y="2660904"/>
-            <a:ext cx="4343400" cy="740664"/>
-          </a:xfrm>
-          <a:prstGeom prst="rect">
-            <a:avLst/>
-          </a:prstGeom>
-          <a:noFill/>
-          <a:ln/>
-        </p:spPr>
-        <p:txBody>
-          <a:bodyPr wrap="square" lIns="0" tIns="0" rIns="0" bIns="0" rtlCol="0" anchor="ctr"/>
-          <a:lstStyle/>
-          <a:p>
-            <a:pPr indent="0" marL="0">
-              <a:buNone/>
-            </a:pPr>
-            <a:r>
-              <a:rPr lang="en-US" sz="1350" dirty="0">
-                <a:solidFill>
-                  <a:srgbClr val="2B2318"/>
-                </a:solidFill>
-                <a:latin typeface="Calibri" pitchFamily="34" charset="0"/>
-                <a:ea typeface="Calibri" pitchFamily="34" charset="-122"/>
-                <a:cs typeface="Calibri" pitchFamily="34" charset="-120"/>
-              </a:rPr>
-              <a:t>Vergleiche mit deinem Nachbarn und ergänze, was dir fehlt.</a:t>
-            </a:r>
-            <a:endParaRPr lang="en-US" sz="1350" dirty="0"/>
-          </a:p>
-        </p:txBody>
-      </p:sp>
-      <p:sp>
-        <p:nvSpPr>
-          <p:cNvPr id="17" name="Text 15"/>
-          <p:cNvSpPr txBox="1"/>
-          <p:nvPr/>
-        </p:nvSpPr>
-        <p:spPr>
-          <a:xfrm>
-            <a:off x="457200" y="3474720"/>
-            <a:ext cx="365760" cy="365760"/>
-          </a:xfrm>
-          <a:prstGeom prst="ellipse">
-            <a:avLst/>
-          </a:prstGeom>
-          <a:solidFill>
-            <a:srgbClr val="AD4426"/>
-          </a:solidFill>
-          <a:ln/>
-        </p:spPr>
-        <p:txBody>
-          <a:bodyPr wrap="square" lIns="0" tIns="0" rIns="0" bIns="0" rtlCol="0" anchor="ctr"/>
-          <a:lstStyle/>
-          <a:p>
-            <a:pPr algn="ctr" indent="0" marL="0">
-              <a:buNone/>
-            </a:pPr>
-            <a:r>
-              <a:rPr lang="en-US" sz="1400" b="1" dirty="0">
-                <a:solidFill>
-                  <a:srgbClr val="FFFFFF"/>
-                </a:solidFill>
-                <a:latin typeface="Cambria" pitchFamily="34" charset="0"/>
-                <a:ea typeface="Cambria" pitchFamily="34" charset="-122"/>
-                <a:cs typeface="Cambria" pitchFamily="34" charset="-120"/>
-              </a:rPr>
-              <a:t>3</a:t>
-            </a:r>
-            <a:endParaRPr lang="en-US" sz="1400" dirty="0"/>
-          </a:p>
-        </p:txBody>
-      </p:sp>
-      <p:sp>
-        <p:nvSpPr>
-          <p:cNvPr id="18" name="Text 16"/>
-          <p:cNvSpPr txBox="1"/>
-          <p:nvPr/>
-        </p:nvSpPr>
-        <p:spPr>
-          <a:xfrm>
-            <a:off x="960120" y="3438144"/>
-            <a:ext cx="4343400" cy="740664"/>
-          </a:xfrm>
-          <a:prstGeom prst="rect">
-            <a:avLst/>
-          </a:prstGeom>
-          <a:noFill/>
-          <a:ln/>
-        </p:spPr>
-        <p:txBody>
-          <a:bodyPr wrap="square" lIns="0" tIns="0" rIns="0" bIns="0" rtlCol="0" anchor="ctr"/>
-          <a:lstStyle/>
-          <a:p>
-            <a:pPr indent="0" marL="0">
-              <a:buNone/>
-            </a:pPr>
-            <a:r>
-              <a:rPr lang="en-US" sz="1350" dirty="0">
-                <a:solidFill>
-                  <a:srgbClr val="2B2318"/>
-                </a:solidFill>
-                <a:latin typeface="Calibri" pitchFamily="34" charset="0"/>
-                <a:ea typeface="Calibri" pitchFamily="34" charset="-122"/>
-                <a:cs typeface="Calibri" pitchFamily="34" charset="-120"/>
-              </a:rPr>
-              <a:t>Wer aufgerufen wird, nennt ein Feld und eine Maßnahme. Die Lehrkraft trägt ein.</a:t>
-            </a:r>
-            <a:endParaRPr lang="en-US" sz="1350" dirty="0"/>
-          </a:p>
-        </p:txBody>
-      </p:sp>
-      <p:pic>
-        <p:nvPicPr>
-          <p:cNvPr id="19" name="Image 0" descr="/home/user/Schule/Geschichte_11/Stunde_Peisistratos/Tafelbild_stumm.png">    </p:cNvPr>
-          <p:cNvPicPr>
-            <a:picLocks noChangeAspect="1"/>
-          </p:cNvPicPr>
-          <p:nvPr/>
-        </p:nvPicPr>
-        <p:blipFill>
-          <a:blip r:embed="rId1"/>
-          <a:stretch>
-            <a:fillRect/>
-          </a:stretch>
-        </p:blipFill>
-        <p:spPr>
-          <a:xfrm>
-            <a:off x="5577840" y="1874520"/>
-            <a:ext cx="2926080" cy="2907792"/>
-          </a:xfrm>
-          <a:prstGeom prst="rect">
-            <a:avLst/>
-          </a:prstGeom>
-        </p:spPr>
-      </p:pic>
-      <p:sp>
-        <p:nvSpPr>
-          <p:cNvPr id="20" name="Text 17"/>
-          <p:cNvSpPr txBox="1"/>
-          <p:nvPr/>
-        </p:nvSpPr>
-        <p:spPr>
-          <a:xfrm>
-            <a:off x="457200" y="4773168"/>
-            <a:ext cx="5486400" cy="182880"/>
-          </a:xfrm>
-          <a:prstGeom prst="rect">
-            <a:avLst/>
-          </a:prstGeom>
-          <a:noFill/>
-          <a:ln/>
-        </p:spPr>
-        <p:txBody>
-          <a:bodyPr wrap="square" lIns="0" tIns="0" rIns="0" bIns="0" rtlCol="0" anchor="t"/>
-          <a:lstStyle/>
-          <a:p>
-            <a:pPr indent="0" marL="0">
-              <a:buNone/>
-            </a:pPr>
-            <a:r>
-              <a:rPr lang="en-US" sz="900" dirty="0">
-                <a:solidFill>
-                  <a:srgbClr val="998C77"/>
-                </a:solidFill>
-                <a:latin typeface="Calibri" pitchFamily="34" charset="0"/>
-                <a:ea typeface="Calibri" pitchFamily="34" charset="-122"/>
-                <a:cs typeface="Calibri" pitchFamily="34" charset="-120"/>
-              </a:rPr>
-              <a:t>Kleisthenes – Warum stimmt Lysias anders?</a:t>
-            </a:r>
-            <a:endParaRPr lang="en-US" sz="900" dirty="0"/>
-          </a:p>
-        </p:txBody>
-      </p:sp>
-      <p:sp>
-        <p:nvSpPr>
-          <p:cNvPr id="25" name="Slide Number Placeholder 0"/>
-          <p:cNvSpPr>
-            <a:spLocks noGrp="1"/>
-          </p:cNvSpPr>
-          <p:nvPr>
-            <p:ph type="sldNum" sz="quarter" idx="4294967295"/>
-          </p:nvPr>
-        </p:nvSpPr>
-        <p:spPr>
-          <a:xfrm>
-            <a:off x="8229600" y="4727448"/>
-            <a:ext cx="457200" cy="228600"/>
-          </a:xfrm>
-          <a:prstGeom prst="rect">
-            <a:avLst/>
-          </a:prstGeom>
-          <a:extLst>
-            <a:ext uri="{C572A759-6A51-4108-AA02-DFA0A04FC94B}">
-              <ma14:wrappingTextBoxFlag xmlns:ma14="http://schemas.microsoft.com/office/mac/drawingml/2011/main" val="0"/>
-            </a:ext>
-          </a:extLst>
-        </p:spPr>
-        <p:txBody>
-          <a:bodyPr/>
-          <a:lstStyle>
-            <a:lvl1pPr>
-              <a:defRPr sz="900">
-                <a:solidFill>
-                  <a:srgbClr val="998C77"/>
-                </a:solidFill>
-                <a:latin typeface="Calibri"/>
-                <a:ea typeface="Calibri"/>
-                <a:cs typeface="Calibri"/>
-              </a:defRPr>
-            </a:lvl1pPr>
-          </a:lstStyle>
-          <a:p>
-            <a:pPr algn="r"/>
-            <a:fld id="{F7021451-1387-4CA6-816F-3879F97B5CBC}" type="slidenum">
-              <a:rPr b="0" lang="en-US"/>
-              <a:t>3</a:t>
-            </a:fld>
-            <a:endParaRPr lang="en-US"/>
+              <a:t>Finde die 6 Fehler und berichtige sie im Heft. Dann vergleiche mit deinem Nachbarn.</a:t>
+            </a:r>
+            <a:endParaRPr lang="en-US" sz="1150" dirty="0"/>
           </a:p>
         </p:txBody>
       </p:sp>
@@ -9559,7 +10268,7 @@
                 <a:ea typeface="Cambria" pitchFamily="34" charset="-122"/>
                 <a:cs typeface="Cambria" pitchFamily="34" charset="-120"/>
               </a:rPr>
-              <a:t>Peisistratos: Wegbereiter der Demokratie?</a:t>
+              <a:t>Die richtige Übersicht</a:t>
             </a:r>
             <a:endParaRPr lang="en-US" sz="2600" dirty="0"/>
           </a:p>
@@ -9608,52 +10317,200 @@
           </a:p>
         </p:txBody>
       </p:sp>
-      <p:pic>
-        <p:nvPicPr>
-          <p:cNvPr id="11" name="Image 0" descr="/home/user/Schule/Geschichte_11/Stunde_Peisistratos/Tafelbild_Loesung.png">    </p:cNvPr>
-          <p:cNvPicPr>
-            <a:picLocks noChangeAspect="1"/>
-          </p:cNvPicPr>
-          <p:nvPr/>
-        </p:nvPicPr>
-        <p:blipFill>
-          <a:blip r:embed="rId1"/>
-          <a:stretch>
-            <a:fillRect/>
-          </a:stretch>
-        </p:blipFill>
-        <p:spPr>
-          <a:xfrm>
-            <a:off x="365760" y="1188720"/>
-            <a:ext cx="4754880" cy="3154680"/>
-          </a:xfrm>
-          <a:prstGeom prst="rect">
-            <a:avLst/>
-          </a:prstGeom>
-        </p:spPr>
-      </p:pic>
-      <p:sp>
-        <p:nvSpPr>
-          <p:cNvPr id="12" name="Shape 9"/>
-          <p:cNvSpPr/>
-          <p:nvPr/>
-        </p:nvSpPr>
-        <p:spPr>
-          <a:xfrm>
-            <a:off x="5349240" y="1188720"/>
-            <a:ext cx="3337560" cy="3291840"/>
+      <p:sp>
+        <p:nvSpPr>
+          <p:cNvPr id="11" name="Text 9"/>
+          <p:cNvSpPr txBox="1"/>
+          <p:nvPr/>
+        </p:nvSpPr>
+        <p:spPr>
+          <a:xfrm>
+            <a:off x="457200" y="1097280"/>
+            <a:ext cx="914400" cy="274320"/>
           </a:xfrm>
           <a:prstGeom prst="roundRect">
             <a:avLst>
-              <a:gd name="adj" fmla="val 2222"/>
+              <a:gd name="adj" fmla="val 26667"/>
             </a:avLst>
           </a:prstGeom>
           <a:solidFill>
-            <a:srgbClr val="F4ECDE"/>
+            <a:srgbClr val="2B2318"/>
+          </a:solidFill>
+          <a:ln/>
+        </p:spPr>
+        <p:txBody>
+          <a:bodyPr wrap="square" lIns="0" tIns="0" rIns="0" bIns="0" rtlCol="0" anchor="ctr"/>
+          <a:lstStyle/>
+          <a:p>
+            <a:pPr algn="ctr" indent="0" marL="0">
+              <a:buNone/>
+            </a:pPr>
+            <a:r>
+              <a:rPr lang="en-US" sz="1150" b="1" dirty="0">
+                <a:solidFill>
+                  <a:srgbClr val="FFFFFF"/>
+                </a:solidFill>
+                <a:latin typeface="Calibri" pitchFamily="34" charset="0"/>
+                <a:ea typeface="Calibri" pitchFamily="34" charset="-122"/>
+                <a:cs typeface="Calibri" pitchFamily="34" charset="-120"/>
+              </a:rPr>
+              <a:t>Zeit</a:t>
+            </a:r>
+            <a:endParaRPr lang="en-US" sz="1150" dirty="0"/>
+          </a:p>
+        </p:txBody>
+      </p:sp>
+      <p:sp>
+        <p:nvSpPr>
+          <p:cNvPr id="12" name="Text 10"/>
+          <p:cNvSpPr txBox="1"/>
+          <p:nvPr/>
+        </p:nvSpPr>
+        <p:spPr>
+          <a:xfrm>
+            <a:off x="1417320" y="1097280"/>
+            <a:ext cx="1234440" cy="274320"/>
+          </a:xfrm>
+          <a:prstGeom prst="roundRect">
+            <a:avLst>
+              <a:gd name="adj" fmla="val 26667"/>
+            </a:avLst>
+          </a:prstGeom>
+          <a:solidFill>
+            <a:srgbClr val="2B2318"/>
+          </a:solidFill>
+          <a:ln/>
+        </p:spPr>
+        <p:txBody>
+          <a:bodyPr wrap="square" lIns="0" tIns="0" rIns="0" bIns="0" rtlCol="0" anchor="ctr"/>
+          <a:lstStyle/>
+          <a:p>
+            <a:pPr algn="ctr" indent="0" marL="0">
+              <a:buNone/>
+            </a:pPr>
+            <a:r>
+              <a:rPr lang="en-US" sz="1150" b="1" dirty="0">
+                <a:solidFill>
+                  <a:srgbClr val="FFFFFF"/>
+                </a:solidFill>
+                <a:latin typeface="Calibri" pitchFamily="34" charset="0"/>
+                <a:ea typeface="Calibri" pitchFamily="34" charset="-122"/>
+                <a:cs typeface="Calibri" pitchFamily="34" charset="-120"/>
+              </a:rPr>
+              <a:t>Herrschaftsform</a:t>
+            </a:r>
+            <a:endParaRPr lang="en-US" sz="1150" dirty="0"/>
+          </a:p>
+        </p:txBody>
+      </p:sp>
+      <p:sp>
+        <p:nvSpPr>
+          <p:cNvPr id="13" name="Text 11"/>
+          <p:cNvSpPr txBox="1"/>
+          <p:nvPr/>
+        </p:nvSpPr>
+        <p:spPr>
+          <a:xfrm>
+            <a:off x="2697480" y="1097280"/>
+            <a:ext cx="1325880" cy="274320"/>
+          </a:xfrm>
+          <a:prstGeom prst="roundRect">
+            <a:avLst>
+              <a:gd name="adj" fmla="val 26667"/>
+            </a:avLst>
+          </a:prstGeom>
+          <a:solidFill>
+            <a:srgbClr val="2B2318"/>
+          </a:solidFill>
+          <a:ln/>
+        </p:spPr>
+        <p:txBody>
+          <a:bodyPr wrap="square" lIns="0" tIns="0" rIns="0" bIns="0" rtlCol="0" anchor="ctr"/>
+          <a:lstStyle/>
+          <a:p>
+            <a:pPr algn="ctr" indent="0" marL="0">
+              <a:buNone/>
+            </a:pPr>
+            <a:r>
+              <a:rPr lang="en-US" sz="1150" b="1" dirty="0">
+                <a:solidFill>
+                  <a:srgbClr val="FFFFFF"/>
+                </a:solidFill>
+                <a:latin typeface="Calibri" pitchFamily="34" charset="0"/>
+                <a:ea typeface="Calibri" pitchFamily="34" charset="-122"/>
+                <a:cs typeface="Calibri" pitchFamily="34" charset="-120"/>
+              </a:rPr>
+              <a:t>Protagonist</a:t>
+            </a:r>
+            <a:endParaRPr lang="en-US" sz="1150" dirty="0"/>
+          </a:p>
+        </p:txBody>
+      </p:sp>
+      <p:sp>
+        <p:nvSpPr>
+          <p:cNvPr id="14" name="Text 12"/>
+          <p:cNvSpPr txBox="1"/>
+          <p:nvPr/>
+        </p:nvSpPr>
+        <p:spPr>
+          <a:xfrm>
+            <a:off x="4069080" y="1097280"/>
+            <a:ext cx="4617720" cy="274320"/>
+          </a:xfrm>
+          <a:prstGeom prst="roundRect">
+            <a:avLst>
+              <a:gd name="adj" fmla="val 26667"/>
+            </a:avLst>
+          </a:prstGeom>
+          <a:solidFill>
+            <a:srgbClr val="2B2318"/>
+          </a:solidFill>
+          <a:ln/>
+        </p:spPr>
+        <p:txBody>
+          <a:bodyPr wrap="square" lIns="0" tIns="0" rIns="0" bIns="0" rtlCol="0" anchor="ctr"/>
+          <a:lstStyle/>
+          <a:p>
+            <a:pPr algn="ctr" indent="0" marL="0">
+              <a:buNone/>
+            </a:pPr>
+            <a:r>
+              <a:rPr lang="en-US" sz="1150" b="1" dirty="0">
+                <a:solidFill>
+                  <a:srgbClr val="FFFFFF"/>
+                </a:solidFill>
+                <a:latin typeface="Calibri" pitchFamily="34" charset="0"/>
+                <a:ea typeface="Calibri" pitchFamily="34" charset="-122"/>
+                <a:cs typeface="Calibri" pitchFamily="34" charset="-120"/>
+              </a:rPr>
+              <a:t>Was geschah?</a:t>
+            </a:r>
+            <a:endParaRPr lang="en-US" sz="1150" dirty="0"/>
+          </a:p>
+        </p:txBody>
+      </p:sp>
+      <p:sp>
+        <p:nvSpPr>
+          <p:cNvPr id="15" name="Shape 13"/>
+          <p:cNvSpPr/>
+          <p:nvPr/>
+        </p:nvSpPr>
+        <p:spPr>
+          <a:xfrm>
+            <a:off x="457200" y="1426464"/>
+            <a:ext cx="8229600" cy="694944"/>
+          </a:xfrm>
+          <a:prstGeom prst="roundRect">
+            <a:avLst>
+              <a:gd name="adj" fmla="val 10526"/>
+            </a:avLst>
+          </a:prstGeom>
+          <a:solidFill>
+            <a:srgbClr val="FBF8F2"/>
           </a:solidFill>
           <a:ln w="12700">
             <a:solidFill>
-              <a:srgbClr val="F4ECDE"/>
+              <a:srgbClr val="FBF8F2"/>
             </a:solidFill>
             <a:prstDash val="solid"/>
           </a:ln>
@@ -9661,69 +10518,266 @@
       </p:sp>
       <p:sp>
         <p:nvSpPr>
-          <p:cNvPr id="13" name="Text 10"/>
-          <p:cNvSpPr txBox="1"/>
-          <p:nvPr/>
-        </p:nvSpPr>
-        <p:spPr>
-          <a:xfrm>
-            <a:off x="5532120" y="1280160"/>
-            <a:ext cx="3017520" cy="320040"/>
-          </a:xfrm>
-          <a:prstGeom prst="rect">
-            <a:avLst/>
-          </a:prstGeom>
-          <a:noFill/>
-          <a:ln/>
-        </p:spPr>
-        <p:txBody>
-          <a:bodyPr wrap="square" lIns="0" tIns="0" rIns="0" bIns="0" rtlCol="0" anchor="t"/>
+          <p:cNvPr id="16" name="Text 14"/>
+          <p:cNvSpPr txBox="1"/>
+          <p:nvPr/>
+        </p:nvSpPr>
+        <p:spPr>
+          <a:xfrm>
+            <a:off x="502920" y="1426464"/>
+            <a:ext cx="914400" cy="694944"/>
+          </a:xfrm>
+          <a:prstGeom prst="rect">
+            <a:avLst/>
+          </a:prstGeom>
+          <a:noFill/>
+          <a:ln/>
+        </p:spPr>
+        <p:txBody>
+          <a:bodyPr wrap="square" lIns="0" tIns="0" rIns="0" bIns="0" rtlCol="0" anchor="ctr"/>
           <a:lstStyle/>
           <a:p>
             <a:pPr indent="0" marL="0">
               <a:buNone/>
             </a:pPr>
             <a:r>
-              <a:rPr lang="en-US" sz="1500" b="1" dirty="0">
+              <a:rPr lang="en-US" sz="1200" b="1" dirty="0">
+                <a:solidFill>
+                  <a:srgbClr val="2B2318"/>
+                </a:solidFill>
+                <a:latin typeface="Calibri" pitchFamily="34" charset="0"/>
+                <a:ea typeface="Calibri" pitchFamily="34" charset="-122"/>
+                <a:cs typeface="Calibri" pitchFamily="34" charset="-120"/>
+              </a:rPr>
+              <a:t>vor 600</a:t>
+            </a:r>
+            <a:endParaRPr lang="en-US" sz="1200" dirty="0"/>
+          </a:p>
+        </p:txBody>
+      </p:sp>
+      <p:sp>
+        <p:nvSpPr>
+          <p:cNvPr id="17" name="Text 15"/>
+          <p:cNvSpPr txBox="1"/>
+          <p:nvPr/>
+        </p:nvSpPr>
+        <p:spPr>
+          <a:xfrm>
+            <a:off x="1417320" y="1426464"/>
+            <a:ext cx="1234440" cy="694944"/>
+          </a:xfrm>
+          <a:prstGeom prst="rect">
+            <a:avLst/>
+          </a:prstGeom>
+          <a:noFill/>
+          <a:ln/>
+        </p:spPr>
+        <p:txBody>
+          <a:bodyPr wrap="square" lIns="0" tIns="0" rIns="0" bIns="0" rtlCol="0" anchor="ctr"/>
+          <a:lstStyle/>
+          <a:p>
+            <a:pPr indent="0" marL="0">
+              <a:buNone/>
+            </a:pPr>
+            <a:r>
+              <a:rPr lang="en-US" sz="1250" b="1" dirty="0">
                 <a:solidFill>
                   <a:srgbClr val="AD4426"/>
+                </a:solidFill>
+                <a:latin typeface="Calibri" pitchFamily="34" charset="0"/>
+                <a:ea typeface="Calibri" pitchFamily="34" charset="-122"/>
+                <a:cs typeface="Calibri" pitchFamily="34" charset="-120"/>
+              </a:rPr>
+              <a:t>Aristokratie</a:t>
+            </a:r>
+            <a:endParaRPr lang="en-US" sz="1250" dirty="0"/>
+          </a:p>
+        </p:txBody>
+      </p:sp>
+      <p:sp>
+        <p:nvSpPr>
+          <p:cNvPr id="18" name="Text 16"/>
+          <p:cNvSpPr txBox="1"/>
+          <p:nvPr/>
+        </p:nvSpPr>
+        <p:spPr>
+          <a:xfrm>
+            <a:off x="2697480" y="1426464"/>
+            <a:ext cx="1325880" cy="694944"/>
+          </a:xfrm>
+          <a:prstGeom prst="rect">
+            <a:avLst/>
+          </a:prstGeom>
+          <a:noFill/>
+          <a:ln/>
+        </p:spPr>
+        <p:txBody>
+          <a:bodyPr wrap="square" lIns="0" tIns="0" rIns="0" bIns="0" rtlCol="0" anchor="ctr"/>
+          <a:lstStyle/>
+          <a:p>
+            <a:pPr indent="0" marL="0">
+              <a:buNone/>
+            </a:pPr>
+            <a:r>
+              <a:rPr lang="en-US" sz="1300" b="1" dirty="0">
+                <a:solidFill>
+                  <a:srgbClr val="2B2318"/>
                 </a:solidFill>
                 <a:latin typeface="Cambria" pitchFamily="34" charset="0"/>
                 <a:ea typeface="Cambria" pitchFamily="34" charset="-122"/>
                 <a:cs typeface="Cambria" pitchFamily="34" charset="-120"/>
               </a:rPr>
-              <a:t>Ja – ungewollt:</a:t>
-            </a:r>
-            <a:endParaRPr lang="en-US" sz="1500" dirty="0"/>
-          </a:p>
-        </p:txBody>
-      </p:sp>
-      <p:sp>
-        <p:nvSpPr>
-          <p:cNvPr id="14" name="Text 11"/>
-          <p:cNvSpPr txBox="1"/>
-          <p:nvPr/>
-        </p:nvSpPr>
-        <p:spPr>
-          <a:xfrm>
-            <a:off x="5532120" y="1645920"/>
-            <a:ext cx="3017520" cy="1280160"/>
-          </a:xfrm>
-          <a:prstGeom prst="rect">
-            <a:avLst/>
-          </a:prstGeom>
-          <a:noFill/>
-          <a:ln/>
-        </p:spPr>
-        <p:txBody>
-          <a:bodyPr wrap="square" lIns="0" tIns="0" rIns="0" bIns="0" rtlCol="0" anchor="t"/>
+              <a:t>Adelsfamilien</a:t>
+            </a:r>
+            <a:endParaRPr lang="en-US" sz="1300" dirty="0"/>
+          </a:p>
+        </p:txBody>
+      </p:sp>
+      <p:sp>
+        <p:nvSpPr>
+          <p:cNvPr id="19" name="Text 17"/>
+          <p:cNvSpPr txBox="1"/>
+          <p:nvPr/>
+        </p:nvSpPr>
+        <p:spPr>
+          <a:xfrm>
+            <a:off x="4069080" y="1453896"/>
+            <a:ext cx="4617720" cy="329184"/>
+          </a:xfrm>
+          <a:prstGeom prst="rect">
+            <a:avLst/>
+          </a:prstGeom>
+          <a:noFill/>
+          <a:ln/>
+        </p:spPr>
+        <p:txBody>
+          <a:bodyPr wrap="square" lIns="0" tIns="0" rIns="0" bIns="0" rtlCol="0" anchor="ctr"/>
           <a:lstStyle/>
           <a:p>
             <a:pPr indent="0" marL="0">
               <a:buNone/>
             </a:pPr>
             <a:r>
-              <a:rPr lang="en-US" sz="1300" dirty="0">
+              <a:rPr lang="en-US" sz="1150" dirty="0">
+                <a:solidFill>
+                  <a:srgbClr val="3C783C"/>
+                </a:solidFill>
+                <a:latin typeface="Calibri" pitchFamily="34" charset="0"/>
+                <a:ea typeface="Calibri" pitchFamily="34" charset="-122"/>
+                <a:cs typeface="Calibri" pitchFamily="34" charset="-120"/>
+              </a:rPr>
+              <a:t>✓ Die Macht liegt bei wenigen Adelsfamilien; aus ihnen kommen die Archonten.</a:t>
+            </a:r>
+            <a:endParaRPr lang="en-US" sz="1150" dirty="0"/>
+          </a:p>
+        </p:txBody>
+      </p:sp>
+      <p:sp>
+        <p:nvSpPr>
+          <p:cNvPr id="20" name="Text 18"/>
+          <p:cNvSpPr txBox="1"/>
+          <p:nvPr/>
+        </p:nvSpPr>
+        <p:spPr>
+          <a:xfrm>
+            <a:off x="4069080" y="1783080"/>
+            <a:ext cx="4617720" cy="329184"/>
+          </a:xfrm>
+          <a:prstGeom prst="rect">
+            <a:avLst/>
+          </a:prstGeom>
+          <a:noFill/>
+          <a:ln/>
+        </p:spPr>
+        <p:txBody>
+          <a:bodyPr wrap="square" lIns="0" tIns="0" rIns="0" bIns="0" rtlCol="0" anchor="ctr"/>
+          <a:lstStyle/>
+          <a:p>
+            <a:pPr indent="0" marL="0">
+              <a:buNone/>
+            </a:pPr>
+            <a:r>
+              <a:rPr lang="en-US" sz="1150" b="1" dirty="0">
+                <a:solidFill>
+                  <a:srgbClr val="AD4426"/>
+                </a:solidFill>
+                <a:latin typeface="Calibri" pitchFamily="34" charset="0"/>
+                <a:ea typeface="Calibri" pitchFamily="34" charset="-122"/>
+                <a:cs typeface="Calibri" pitchFamily="34" charset="-120"/>
+              </a:rPr>
+              <a:t>✗ </a:t>
+            </a:r>
+            <a:pPr indent="0" marL="0">
+              <a:buNone/>
+            </a:pPr>
+            <a:r>
+              <a:rPr lang="en-US" sz="1150" b="1" dirty="0">
+                <a:solidFill>
+                  <a:srgbClr val="AD4426"/>
+                </a:solidFill>
+                <a:latin typeface="Calibri" pitchFamily="34" charset="0"/>
+                <a:ea typeface="Calibri" pitchFamily="34" charset="-122"/>
+                <a:cs typeface="Calibri" pitchFamily="34" charset="-120"/>
+              </a:rPr>
+              <a:t>Recht spricht der Adel – geschriebene Gesetze gibt es nicht.</a:t>
+            </a:r>
+            <a:endParaRPr lang="en-US" sz="1150" dirty="0"/>
+          </a:p>
+        </p:txBody>
+      </p:sp>
+      <p:sp>
+        <p:nvSpPr>
+          <p:cNvPr id="21" name="Shape 19"/>
+          <p:cNvSpPr/>
+          <p:nvPr/>
+        </p:nvSpPr>
+        <p:spPr>
+          <a:xfrm>
+            <a:off x="457200" y="2157984"/>
+            <a:ext cx="8229600" cy="694944"/>
+          </a:xfrm>
+          <a:prstGeom prst="roundRect">
+            <a:avLst>
+              <a:gd name="adj" fmla="val 10526"/>
+            </a:avLst>
+          </a:prstGeom>
+          <a:solidFill>
+            <a:srgbClr val="FFFFFF"/>
+          </a:solidFill>
+          <a:ln w="12700">
+            <a:solidFill>
+              <a:srgbClr val="FFFFFF"/>
+            </a:solidFill>
+            <a:prstDash val="solid"/>
+          </a:ln>
+        </p:spPr>
+      </p:sp>
+      <p:sp>
+        <p:nvSpPr>
+          <p:cNvPr id="22" name="Text 20"/>
+          <p:cNvSpPr txBox="1"/>
+          <p:nvPr/>
+        </p:nvSpPr>
+        <p:spPr>
+          <a:xfrm>
+            <a:off x="502920" y="2157984"/>
+            <a:ext cx="914400" cy="694944"/>
+          </a:xfrm>
+          <a:prstGeom prst="rect">
+            <a:avLst/>
+          </a:prstGeom>
+          <a:noFill/>
+          <a:ln/>
+        </p:spPr>
+        <p:txBody>
+          <a:bodyPr wrap="square" lIns="0" tIns="0" rIns="0" bIns="0" rtlCol="0" anchor="ctr"/>
+          <a:lstStyle/>
+          <a:p>
+            <a:pPr indent="0" marL="0">
+              <a:buNone/>
+            </a:pPr>
+            <a:r>
+              <a:rPr lang="en-US" sz="1200" b="1" dirty="0">
                 <a:solidFill>
                   <a:srgbClr val="2B2318"/>
                 </a:solidFill>
@@ -9731,77 +10785,235 @@
                 <a:ea typeface="Calibri" pitchFamily="34" charset="-122"/>
                 <a:cs typeface="Calibri" pitchFamily="34" charset="-120"/>
               </a:rPr>
-              <a:t>Bauern und Mittelstand werden unabhängiger, das Volk wächst zusammen, die mächtigsten Gegner aus dem Adel verlieren.</a:t>
-            </a:r>
-            <a:endParaRPr lang="en-US" sz="1300" dirty="0"/>
-          </a:p>
-        </p:txBody>
-      </p:sp>
-      <p:sp>
-        <p:nvSpPr>
-          <p:cNvPr id="15" name="Text 12"/>
-          <p:cNvSpPr txBox="1"/>
-          <p:nvPr/>
-        </p:nvSpPr>
-        <p:spPr>
-          <a:xfrm>
-            <a:off x="5532120" y="2926080"/>
-            <a:ext cx="3017520" cy="274320"/>
-          </a:xfrm>
-          <a:prstGeom prst="rect">
-            <a:avLst/>
-          </a:prstGeom>
-          <a:noFill/>
-          <a:ln/>
-        </p:spPr>
-        <p:txBody>
-          <a:bodyPr wrap="square" lIns="0" tIns="0" rIns="0" bIns="0" rtlCol="0" anchor="t"/>
+              <a:t>624/621</a:t>
+            </a:r>
+            <a:endParaRPr lang="en-US" sz="1200" dirty="0"/>
+          </a:p>
+        </p:txBody>
+      </p:sp>
+      <p:sp>
+        <p:nvSpPr>
+          <p:cNvPr id="23" name="Text 21"/>
+          <p:cNvSpPr txBox="1"/>
+          <p:nvPr/>
+        </p:nvSpPr>
+        <p:spPr>
+          <a:xfrm>
+            <a:off x="1417320" y="2157984"/>
+            <a:ext cx="1234440" cy="694944"/>
+          </a:xfrm>
+          <a:prstGeom prst="rect">
+            <a:avLst/>
+          </a:prstGeom>
+          <a:noFill/>
+          <a:ln/>
+        </p:spPr>
+        <p:txBody>
+          <a:bodyPr wrap="square" lIns="0" tIns="0" rIns="0" bIns="0" rtlCol="0" anchor="ctr"/>
           <a:lstStyle/>
           <a:p>
             <a:pPr indent="0" marL="0">
               <a:buNone/>
             </a:pPr>
             <a:r>
-              <a:rPr lang="en-US" sz="1500" b="1" dirty="0">
+              <a:rPr lang="en-US" sz="1250" b="1" dirty="0">
                 <a:solidFill>
                   <a:srgbClr val="AD4426"/>
+                </a:solidFill>
+                <a:latin typeface="Calibri" pitchFamily="34" charset="0"/>
+                <a:ea typeface="Calibri" pitchFamily="34" charset="-122"/>
+                <a:cs typeface="Calibri" pitchFamily="34" charset="-120"/>
+              </a:rPr>
+              <a:t>Aristokratie</a:t>
+            </a:r>
+            <a:endParaRPr lang="en-US" sz="1250" dirty="0"/>
+          </a:p>
+        </p:txBody>
+      </p:sp>
+      <p:sp>
+        <p:nvSpPr>
+          <p:cNvPr id="24" name="Text 22"/>
+          <p:cNvSpPr txBox="1"/>
+          <p:nvPr/>
+        </p:nvSpPr>
+        <p:spPr>
+          <a:xfrm>
+            <a:off x="2697480" y="2157984"/>
+            <a:ext cx="1325880" cy="694944"/>
+          </a:xfrm>
+          <a:prstGeom prst="rect">
+            <a:avLst/>
+          </a:prstGeom>
+          <a:noFill/>
+          <a:ln/>
+        </p:spPr>
+        <p:txBody>
+          <a:bodyPr wrap="square" lIns="0" tIns="0" rIns="0" bIns="0" rtlCol="0" anchor="ctr"/>
+          <a:lstStyle/>
+          <a:p>
+            <a:pPr indent="0" marL="0">
+              <a:buNone/>
+            </a:pPr>
+            <a:r>
+              <a:rPr lang="en-US" sz="1300" b="1" dirty="0">
+                <a:solidFill>
+                  <a:srgbClr val="2B2318"/>
                 </a:solidFill>
                 <a:latin typeface="Cambria" pitchFamily="34" charset="0"/>
                 <a:ea typeface="Cambria" pitchFamily="34" charset="-122"/>
                 <a:cs typeface="Cambria" pitchFamily="34" charset="-120"/>
               </a:rPr>
-              <a:t>Aber:</a:t>
-            </a:r>
-            <a:endParaRPr lang="en-US" sz="1500" dirty="0"/>
-          </a:p>
-        </p:txBody>
-      </p:sp>
-      <p:sp>
-        <p:nvSpPr>
-          <p:cNvPr id="16" name="Text 13"/>
-          <p:cNvSpPr txBox="1"/>
-          <p:nvPr/>
-        </p:nvSpPr>
-        <p:spPr>
-          <a:xfrm>
-            <a:off x="5532120" y="3246120"/>
-            <a:ext cx="3017520" cy="1097280"/>
-          </a:xfrm>
-          <a:prstGeom prst="rect">
-            <a:avLst/>
-          </a:prstGeom>
-          <a:noFill/>
-          <a:ln/>
-        </p:spPr>
-        <p:txBody>
-          <a:bodyPr wrap="square" lIns="0" tIns="0" rIns="0" bIns="0" rtlCol="0" anchor="t"/>
+              <a:t>Drakon</a:t>
+            </a:r>
+            <a:endParaRPr lang="en-US" sz="1300" dirty="0"/>
+          </a:p>
+        </p:txBody>
+      </p:sp>
+      <p:sp>
+        <p:nvSpPr>
+          <p:cNvPr id="25" name="Text 23"/>
+          <p:cNvSpPr txBox="1"/>
+          <p:nvPr/>
+        </p:nvSpPr>
+        <p:spPr>
+          <a:xfrm>
+            <a:off x="4069080" y="2185416"/>
+            <a:ext cx="4617720" cy="329184"/>
+          </a:xfrm>
+          <a:prstGeom prst="rect">
+            <a:avLst/>
+          </a:prstGeom>
+          <a:noFill/>
+          <a:ln/>
+        </p:spPr>
+        <p:txBody>
+          <a:bodyPr wrap="square" lIns="0" tIns="0" rIns="0" bIns="0" rtlCol="0" anchor="ctr"/>
           <a:lstStyle/>
           <a:p>
             <a:pPr indent="0" marL="0">
               <a:buNone/>
             </a:pPr>
             <a:r>
-              <a:rPr lang="en-US" sz="1300" dirty="0">
+              <a:rPr lang="en-US" sz="1150" dirty="0">
+                <a:solidFill>
+                  <a:srgbClr val="3C783C"/>
+                </a:solidFill>
+                <a:latin typeface="Calibri" pitchFamily="34" charset="0"/>
+                <a:ea typeface="Calibri" pitchFamily="34" charset="-122"/>
+                <a:cs typeface="Calibri" pitchFamily="34" charset="-120"/>
+              </a:rPr>
+              <a:t>✓ Er schreibt das Recht erstmals auf; staatliche Richter ersetzen die Blutrache.</a:t>
+            </a:r>
+            <a:endParaRPr lang="en-US" sz="1150" dirty="0"/>
+          </a:p>
+        </p:txBody>
+      </p:sp>
+      <p:sp>
+        <p:nvSpPr>
+          <p:cNvPr id="26" name="Text 24"/>
+          <p:cNvSpPr txBox="1"/>
+          <p:nvPr/>
+        </p:nvSpPr>
+        <p:spPr>
+          <a:xfrm>
+            <a:off x="4069080" y="2514600"/>
+            <a:ext cx="4617720" cy="329184"/>
+          </a:xfrm>
+          <a:prstGeom prst="rect">
+            <a:avLst/>
+          </a:prstGeom>
+          <a:noFill/>
+          <a:ln/>
+        </p:spPr>
+        <p:txBody>
+          <a:bodyPr wrap="square" lIns="0" tIns="0" rIns="0" bIns="0" rtlCol="0" anchor="ctr"/>
+          <a:lstStyle/>
+          <a:p>
+            <a:pPr indent="0" marL="0">
+              <a:buNone/>
+            </a:pPr>
+            <a:r>
+              <a:rPr lang="en-US" sz="1150" b="1" dirty="0">
+                <a:solidFill>
+                  <a:srgbClr val="AD4426"/>
+                </a:solidFill>
+                <a:latin typeface="Calibri" pitchFamily="34" charset="0"/>
+                <a:ea typeface="Calibri" pitchFamily="34" charset="-122"/>
+                <a:cs typeface="Calibri" pitchFamily="34" charset="-120"/>
+              </a:rPr>
+              <a:t>✗ </a:t>
+            </a:r>
+            <a:pPr indent="0" marL="0">
+              <a:buNone/>
+            </a:pPr>
+            <a:r>
+              <a:rPr lang="en-US" sz="1150" b="1" dirty="0">
+                <a:solidFill>
+                  <a:srgbClr val="AD4426"/>
+                </a:solidFill>
+                <a:latin typeface="Calibri" pitchFamily="34" charset="0"/>
+                <a:ea typeface="Calibri" pitchFamily="34" charset="-122"/>
+                <a:cs typeface="Calibri" pitchFamily="34" charset="-120"/>
+              </a:rPr>
+              <a:t>Die Schuldknechtschaft bleibt bestehen.</a:t>
+            </a:r>
+            <a:endParaRPr lang="en-US" sz="1150" dirty="0"/>
+          </a:p>
+        </p:txBody>
+      </p:sp>
+      <p:sp>
+        <p:nvSpPr>
+          <p:cNvPr id="27" name="Shape 25"/>
+          <p:cNvSpPr/>
+          <p:nvPr/>
+        </p:nvSpPr>
+        <p:spPr>
+          <a:xfrm>
+            <a:off x="457200" y="2889504"/>
+            <a:ext cx="8229600" cy="694944"/>
+          </a:xfrm>
+          <a:prstGeom prst="roundRect">
+            <a:avLst>
+              <a:gd name="adj" fmla="val 10526"/>
+            </a:avLst>
+          </a:prstGeom>
+          <a:solidFill>
+            <a:srgbClr val="FBF8F2"/>
+          </a:solidFill>
+          <a:ln w="12700">
+            <a:solidFill>
+              <a:srgbClr val="FBF8F2"/>
+            </a:solidFill>
+            <a:prstDash val="solid"/>
+          </a:ln>
+        </p:spPr>
+      </p:sp>
+      <p:sp>
+        <p:nvSpPr>
+          <p:cNvPr id="28" name="Text 26"/>
+          <p:cNvSpPr txBox="1"/>
+          <p:nvPr/>
+        </p:nvSpPr>
+        <p:spPr>
+          <a:xfrm>
+            <a:off x="502920" y="2889504"/>
+            <a:ext cx="914400" cy="694944"/>
+          </a:xfrm>
+          <a:prstGeom prst="rect">
+            <a:avLst/>
+          </a:prstGeom>
+          <a:noFill/>
+          <a:ln/>
+        </p:spPr>
+        <p:txBody>
+          <a:bodyPr wrap="square" lIns="0" tIns="0" rIns="0" bIns="0" rtlCol="0" anchor="ctr"/>
+          <a:lstStyle/>
+          <a:p>
+            <a:pPr indent="0" marL="0">
+              <a:buNone/>
+            </a:pPr>
+            <a:r>
+              <a:rPr lang="en-US" sz="1200" b="1" dirty="0">
                 <a:solidFill>
                   <a:srgbClr val="2B2318"/>
                 </a:solidFill>
@@ -9809,7 +11021,85 @@
                 <a:ea typeface="Calibri" pitchFamily="34" charset="-122"/>
                 <a:cs typeface="Calibri" pitchFamily="34" charset="-120"/>
               </a:rPr>
-              <a:t>Die Macht hängt an einem Mann – und die Adelsfamilien bestimmen weiter über ihre Anhänger.</a:t>
+              <a:t>594/93</a:t>
+            </a:r>
+            <a:endParaRPr lang="en-US" sz="1200" dirty="0"/>
+          </a:p>
+        </p:txBody>
+      </p:sp>
+      <p:sp>
+        <p:nvSpPr>
+          <p:cNvPr id="29" name="Text 27"/>
+          <p:cNvSpPr txBox="1"/>
+          <p:nvPr/>
+        </p:nvSpPr>
+        <p:spPr>
+          <a:xfrm>
+            <a:off x="1417320" y="2889504"/>
+            <a:ext cx="1234440" cy="694944"/>
+          </a:xfrm>
+          <a:prstGeom prst="rect">
+            <a:avLst/>
+          </a:prstGeom>
+          <a:noFill/>
+          <a:ln/>
+        </p:spPr>
+        <p:txBody>
+          <a:bodyPr wrap="square" lIns="0" tIns="0" rIns="0" bIns="0" rtlCol="0" anchor="ctr"/>
+          <a:lstStyle/>
+          <a:p>
+            <a:pPr indent="0" marL="0">
+              <a:buNone/>
+            </a:pPr>
+            <a:r>
+              <a:rPr lang="en-US" sz="1250" b="1" dirty="0">
+                <a:solidFill>
+                  <a:srgbClr val="AD4426"/>
+                </a:solidFill>
+                <a:latin typeface="Calibri" pitchFamily="34" charset="0"/>
+                <a:ea typeface="Calibri" pitchFamily="34" charset="-122"/>
+                <a:cs typeface="Calibri" pitchFamily="34" charset="-120"/>
+              </a:rPr>
+              <a:t>Timokratie</a:t>
+            </a:r>
+            <a:endParaRPr lang="en-US" sz="1250" dirty="0"/>
+          </a:p>
+        </p:txBody>
+      </p:sp>
+      <p:sp>
+        <p:nvSpPr>
+          <p:cNvPr id="30" name="Text 28"/>
+          <p:cNvSpPr txBox="1"/>
+          <p:nvPr/>
+        </p:nvSpPr>
+        <p:spPr>
+          <a:xfrm>
+            <a:off x="2697480" y="2889504"/>
+            <a:ext cx="1325880" cy="694944"/>
+          </a:xfrm>
+          <a:prstGeom prst="rect">
+            <a:avLst/>
+          </a:prstGeom>
+          <a:noFill/>
+          <a:ln/>
+        </p:spPr>
+        <p:txBody>
+          <a:bodyPr wrap="square" lIns="0" tIns="0" rIns="0" bIns="0" rtlCol="0" anchor="ctr"/>
+          <a:lstStyle/>
+          <a:p>
+            <a:pPr indent="0" marL="0">
+              <a:buNone/>
+            </a:pPr>
+            <a:r>
+              <a:rPr lang="en-US" sz="1300" b="1" dirty="0">
+                <a:solidFill>
+                  <a:srgbClr val="2B2318"/>
+                </a:solidFill>
+                <a:latin typeface="Cambria" pitchFamily="34" charset="0"/>
+                <a:ea typeface="Cambria" pitchFamily="34" charset="-122"/>
+                <a:cs typeface="Cambria" pitchFamily="34" charset="-120"/>
+              </a:rPr>
+              <a:t>Solon</a:t>
             </a:r>
             <a:endParaRPr lang="en-US" sz="1300" dirty="0"/>
           </a:p>
@@ -9817,88 +11107,423 @@
       </p:sp>
       <p:sp>
         <p:nvSpPr>
-          <p:cNvPr id="17" name="Text 14"/>
-          <p:cNvSpPr txBox="1"/>
-          <p:nvPr/>
-        </p:nvSpPr>
-        <p:spPr>
-          <a:xfrm>
-            <a:off x="457200" y="4773168"/>
-            <a:ext cx="5486400" cy="182880"/>
-          </a:xfrm>
-          <a:prstGeom prst="rect">
-            <a:avLst/>
-          </a:prstGeom>
-          <a:noFill/>
-          <a:ln/>
-        </p:spPr>
-        <p:txBody>
-          <a:bodyPr wrap="square" lIns="0" tIns="0" rIns="0" bIns="0" rtlCol="0" anchor="t"/>
+          <p:cNvPr id="31" name="Text 29"/>
+          <p:cNvSpPr txBox="1"/>
+          <p:nvPr/>
+        </p:nvSpPr>
+        <p:spPr>
+          <a:xfrm>
+            <a:off x="4069080" y="2916936"/>
+            <a:ext cx="4617720" cy="329184"/>
+          </a:xfrm>
+          <a:prstGeom prst="rect">
+            <a:avLst/>
+          </a:prstGeom>
+          <a:noFill/>
+          <a:ln/>
+        </p:spPr>
+        <p:txBody>
+          <a:bodyPr wrap="square" lIns="0" tIns="0" rIns="0" bIns="0" rtlCol="0" anchor="ctr"/>
           <a:lstStyle/>
           <a:p>
             <a:pPr indent="0" marL="0">
               <a:buNone/>
             </a:pPr>
             <a:r>
-              <a:rPr lang="en-US" sz="900" dirty="0">
-                <a:solidFill>
-                  <a:srgbClr val="998C77"/>
-                </a:solidFill>
-                <a:latin typeface="Calibri" pitchFamily="34" charset="0"/>
-                <a:ea typeface="Calibri" pitchFamily="34" charset="-122"/>
-                <a:cs typeface="Calibri" pitchFamily="34" charset="-120"/>
-              </a:rPr>
-              <a:t>Kleisthenes – Warum stimmt Lysias anders?</a:t>
-            </a:r>
-            <a:endParaRPr lang="en-US" sz="900" dirty="0"/>
-          </a:p>
-        </p:txBody>
-      </p:sp>
-      <p:sp>
-        <p:nvSpPr>
-          <p:cNvPr id="25" name="Slide Number Placeholder 0"/>
-          <p:cNvSpPr>
-            <a:spLocks noGrp="1"/>
-          </p:cNvSpPr>
-          <p:nvPr>
-            <p:ph type="sldNum" sz="quarter" idx="4294967295"/>
-          </p:nvPr>
-        </p:nvSpPr>
-        <p:spPr>
-          <a:xfrm>
-            <a:off x="8229600" y="4727448"/>
-            <a:ext cx="457200" cy="228600"/>
-          </a:xfrm>
-          <a:prstGeom prst="rect">
-            <a:avLst/>
-          </a:prstGeom>
-          <a:extLst>
-            <a:ext uri="{C572A759-6A51-4108-AA02-DFA0A04FC94B}">
-              <ma14:wrappingTextBoxFlag xmlns:ma14="http://schemas.microsoft.com/office/mac/drawingml/2011/main" val="0"/>
-            </a:ext>
-          </a:extLst>
-        </p:spPr>
-        <p:txBody>
-          <a:bodyPr/>
-          <a:lstStyle>
-            <a:lvl1pPr>
-              <a:defRPr sz="900">
-                <a:solidFill>
-                  <a:srgbClr val="998C77"/>
-                </a:solidFill>
-                <a:latin typeface="Calibri"/>
-                <a:ea typeface="Calibri"/>
-                <a:cs typeface="Calibri"/>
-              </a:defRPr>
-            </a:lvl1pPr>
-          </a:lstStyle>
-          <a:p>
-            <a:pPr algn="r"/>
-            <a:fld id="{F7021451-1387-4CA6-816F-3879F97B5CBC}" type="slidenum">
-              <a:rPr b="0" lang="en-US"/>
-              <a:t>4</a:t>
-            </a:fld>
-            <a:endParaRPr lang="en-US"/>
+              <a:rPr lang="en-US" sz="1150" b="1" dirty="0">
+                <a:solidFill>
+                  <a:srgbClr val="AD4426"/>
+                </a:solidFill>
+                <a:latin typeface="Calibri" pitchFamily="34" charset="0"/>
+                <a:ea typeface="Calibri" pitchFamily="34" charset="-122"/>
+                <a:cs typeface="Calibri" pitchFamily="34" charset="-120"/>
+              </a:rPr>
+              <a:t>✗ </a:t>
+            </a:r>
+            <a:pPr indent="0" marL="0">
+              <a:buNone/>
+            </a:pPr>
+            <a:r>
+              <a:rPr lang="en-US" sz="1150" b="1" dirty="0">
+                <a:solidFill>
+                  <a:srgbClr val="AD4426"/>
+                </a:solidFill>
+                <a:latin typeface="Calibri" pitchFamily="34" charset="0"/>
+                <a:ea typeface="Calibri" pitchFamily="34" charset="-122"/>
+                <a:cs typeface="Calibri" pitchFamily="34" charset="-120"/>
+              </a:rPr>
+              <a:t>Er streicht die Schulden – verteilt aber kein Land neu.</a:t>
+            </a:r>
+            <a:endParaRPr lang="en-US" sz="1150" dirty="0"/>
+          </a:p>
+        </p:txBody>
+      </p:sp>
+      <p:sp>
+        <p:nvSpPr>
+          <p:cNvPr id="32" name="Text 30"/>
+          <p:cNvSpPr txBox="1"/>
+          <p:nvPr/>
+        </p:nvSpPr>
+        <p:spPr>
+          <a:xfrm>
+            <a:off x="4069080" y="3246120"/>
+            <a:ext cx="4617720" cy="329184"/>
+          </a:xfrm>
+          <a:prstGeom prst="rect">
+            <a:avLst/>
+          </a:prstGeom>
+          <a:noFill/>
+          <a:ln/>
+        </p:spPr>
+        <p:txBody>
+          <a:bodyPr wrap="square" lIns="0" tIns="0" rIns="0" bIns="0" rtlCol="0" anchor="ctr"/>
+          <a:lstStyle/>
+          <a:p>
+            <a:pPr indent="0" marL="0">
+              <a:buNone/>
+            </a:pPr>
+            <a:r>
+              <a:rPr lang="en-US" sz="1150" b="1" dirty="0">
+                <a:solidFill>
+                  <a:srgbClr val="AD4426"/>
+                </a:solidFill>
+                <a:latin typeface="Calibri" pitchFamily="34" charset="0"/>
+                <a:ea typeface="Calibri" pitchFamily="34" charset="-122"/>
+                <a:cs typeface="Calibri" pitchFamily="34" charset="-120"/>
+              </a:rPr>
+              <a:t>✗ </a:t>
+            </a:r>
+            <a:pPr indent="0" marL="0">
+              <a:buNone/>
+            </a:pPr>
+            <a:r>
+              <a:rPr lang="en-US" sz="1150" b="1" dirty="0">
+                <a:solidFill>
+                  <a:srgbClr val="AD4426"/>
+                </a:solidFill>
+                <a:latin typeface="Calibri" pitchFamily="34" charset="0"/>
+                <a:ea typeface="Calibri" pitchFamily="34" charset="-122"/>
+                <a:cs typeface="Calibri" pitchFamily="34" charset="-120"/>
+              </a:rPr>
+              <a:t>Die Rechte richten sich nach dem Besitz; Theten dürfen nur abstimmen und klagen.</a:t>
+            </a:r>
+            <a:endParaRPr lang="en-US" sz="1150" dirty="0"/>
+          </a:p>
+        </p:txBody>
+      </p:sp>
+      <p:sp>
+        <p:nvSpPr>
+          <p:cNvPr id="33" name="Shape 31"/>
+          <p:cNvSpPr/>
+          <p:nvPr/>
+        </p:nvSpPr>
+        <p:spPr>
+          <a:xfrm>
+            <a:off x="457200" y="3621024"/>
+            <a:ext cx="8229600" cy="694944"/>
+          </a:xfrm>
+          <a:prstGeom prst="roundRect">
+            <a:avLst>
+              <a:gd name="adj" fmla="val 10526"/>
+            </a:avLst>
+          </a:prstGeom>
+          <a:solidFill>
+            <a:srgbClr val="FFFFFF"/>
+          </a:solidFill>
+          <a:ln w="12700">
+            <a:solidFill>
+              <a:srgbClr val="FFFFFF"/>
+            </a:solidFill>
+            <a:prstDash val="solid"/>
+          </a:ln>
+        </p:spPr>
+      </p:sp>
+      <p:sp>
+        <p:nvSpPr>
+          <p:cNvPr id="34" name="Text 32"/>
+          <p:cNvSpPr txBox="1"/>
+          <p:nvPr/>
+        </p:nvSpPr>
+        <p:spPr>
+          <a:xfrm>
+            <a:off x="502920" y="3621024"/>
+            <a:ext cx="914400" cy="694944"/>
+          </a:xfrm>
+          <a:prstGeom prst="rect">
+            <a:avLst/>
+          </a:prstGeom>
+          <a:noFill/>
+          <a:ln/>
+        </p:spPr>
+        <p:txBody>
+          <a:bodyPr wrap="square" lIns="0" tIns="0" rIns="0" bIns="0" rtlCol="0" anchor="ctr"/>
+          <a:lstStyle/>
+          <a:p>
+            <a:pPr indent="0" marL="0">
+              <a:buNone/>
+            </a:pPr>
+            <a:r>
+              <a:rPr lang="en-US" sz="1200" b="1" dirty="0">
+                <a:solidFill>
+                  <a:srgbClr val="2B2318"/>
+                </a:solidFill>
+                <a:latin typeface="Calibri" pitchFamily="34" charset="0"/>
+                <a:ea typeface="Calibri" pitchFamily="34" charset="-122"/>
+                <a:cs typeface="Calibri" pitchFamily="34" charset="-120"/>
+              </a:rPr>
+              <a:t>546–528/27</a:t>
+            </a:r>
+            <a:endParaRPr lang="en-US" sz="1200" dirty="0"/>
+          </a:p>
+        </p:txBody>
+      </p:sp>
+      <p:sp>
+        <p:nvSpPr>
+          <p:cNvPr id="35" name="Text 33"/>
+          <p:cNvSpPr txBox="1"/>
+          <p:nvPr/>
+        </p:nvSpPr>
+        <p:spPr>
+          <a:xfrm>
+            <a:off x="1417320" y="3621024"/>
+            <a:ext cx="1234440" cy="694944"/>
+          </a:xfrm>
+          <a:prstGeom prst="rect">
+            <a:avLst/>
+          </a:prstGeom>
+          <a:noFill/>
+          <a:ln/>
+        </p:spPr>
+        <p:txBody>
+          <a:bodyPr wrap="square" lIns="0" tIns="0" rIns="0" bIns="0" rtlCol="0" anchor="ctr"/>
+          <a:lstStyle/>
+          <a:p>
+            <a:pPr indent="0" marL="0">
+              <a:buNone/>
+            </a:pPr>
+            <a:r>
+              <a:rPr lang="en-US" sz="1250" b="1" dirty="0">
+                <a:solidFill>
+                  <a:srgbClr val="AD4426"/>
+                </a:solidFill>
+                <a:latin typeface="Calibri" pitchFamily="34" charset="0"/>
+                <a:ea typeface="Calibri" pitchFamily="34" charset="-122"/>
+                <a:cs typeface="Calibri" pitchFamily="34" charset="-120"/>
+              </a:rPr>
+              <a:t>Tyrannis</a:t>
+            </a:r>
+            <a:endParaRPr lang="en-US" sz="1250" dirty="0"/>
+          </a:p>
+        </p:txBody>
+      </p:sp>
+      <p:sp>
+        <p:nvSpPr>
+          <p:cNvPr id="36" name="Text 34"/>
+          <p:cNvSpPr txBox="1"/>
+          <p:nvPr/>
+        </p:nvSpPr>
+        <p:spPr>
+          <a:xfrm>
+            <a:off x="2697480" y="3621024"/>
+            <a:ext cx="1325880" cy="694944"/>
+          </a:xfrm>
+          <a:prstGeom prst="rect">
+            <a:avLst/>
+          </a:prstGeom>
+          <a:noFill/>
+          <a:ln/>
+        </p:spPr>
+        <p:txBody>
+          <a:bodyPr wrap="square" lIns="0" tIns="0" rIns="0" bIns="0" rtlCol="0" anchor="ctr"/>
+          <a:lstStyle/>
+          <a:p>
+            <a:pPr indent="0" marL="0">
+              <a:buNone/>
+            </a:pPr>
+            <a:r>
+              <a:rPr lang="en-US" sz="1300" b="1" dirty="0">
+                <a:solidFill>
+                  <a:srgbClr val="2B2318"/>
+                </a:solidFill>
+                <a:latin typeface="Cambria" pitchFamily="34" charset="0"/>
+                <a:ea typeface="Cambria" pitchFamily="34" charset="-122"/>
+                <a:cs typeface="Cambria" pitchFamily="34" charset="-120"/>
+              </a:rPr>
+              <a:t>Peisistratos</a:t>
+            </a:r>
+            <a:endParaRPr lang="en-US" sz="1300" dirty="0"/>
+          </a:p>
+        </p:txBody>
+      </p:sp>
+      <p:sp>
+        <p:nvSpPr>
+          <p:cNvPr id="37" name="Text 35"/>
+          <p:cNvSpPr txBox="1"/>
+          <p:nvPr/>
+        </p:nvSpPr>
+        <p:spPr>
+          <a:xfrm>
+            <a:off x="4069080" y="3648456"/>
+            <a:ext cx="4617720" cy="329184"/>
+          </a:xfrm>
+          <a:prstGeom prst="rect">
+            <a:avLst/>
+          </a:prstGeom>
+          <a:noFill/>
+          <a:ln/>
+        </p:spPr>
+        <p:txBody>
+          <a:bodyPr wrap="square" lIns="0" tIns="0" rIns="0" bIns="0" rtlCol="0" anchor="ctr"/>
+          <a:lstStyle/>
+          <a:p>
+            <a:pPr indent="0" marL="0">
+              <a:buNone/>
+            </a:pPr>
+            <a:r>
+              <a:rPr lang="en-US" sz="1150" b="1" dirty="0">
+                <a:solidFill>
+                  <a:srgbClr val="AD4426"/>
+                </a:solidFill>
+                <a:latin typeface="Calibri" pitchFamily="34" charset="0"/>
+                <a:ea typeface="Calibri" pitchFamily="34" charset="-122"/>
+                <a:cs typeface="Calibri" pitchFamily="34" charset="-120"/>
+              </a:rPr>
+              <a:t>✗ </a:t>
+            </a:r>
+            <a:pPr indent="0" marL="0">
+              <a:buNone/>
+            </a:pPr>
+            <a:r>
+              <a:rPr lang="en-US" sz="1150" b="1" dirty="0">
+                <a:solidFill>
+                  <a:srgbClr val="AD4426"/>
+                </a:solidFill>
+                <a:latin typeface="Calibri" pitchFamily="34" charset="0"/>
+                <a:ea typeface="Calibri" pitchFamily="34" charset="-122"/>
+                <a:cs typeface="Calibri" pitchFamily="34" charset="-120"/>
+              </a:rPr>
+              <a:t>Er erobert die Macht mit Söldnern (Akropolis).</a:t>
+            </a:r>
+            <a:endParaRPr lang="en-US" sz="1150" dirty="0"/>
+          </a:p>
+        </p:txBody>
+      </p:sp>
+      <p:sp>
+        <p:nvSpPr>
+          <p:cNvPr id="38" name="Text 36"/>
+          <p:cNvSpPr txBox="1"/>
+          <p:nvPr/>
+        </p:nvSpPr>
+        <p:spPr>
+          <a:xfrm>
+            <a:off x="4069080" y="3977640"/>
+            <a:ext cx="4617720" cy="329184"/>
+          </a:xfrm>
+          <a:prstGeom prst="rect">
+            <a:avLst/>
+          </a:prstGeom>
+          <a:noFill/>
+          <a:ln/>
+        </p:spPr>
+        <p:txBody>
+          <a:bodyPr wrap="square" lIns="0" tIns="0" rIns="0" bIns="0" rtlCol="0" anchor="ctr"/>
+          <a:lstStyle/>
+          <a:p>
+            <a:pPr indent="0" marL="0">
+              <a:buNone/>
+            </a:pPr>
+            <a:r>
+              <a:rPr lang="en-US" sz="1150" b="1" dirty="0">
+                <a:solidFill>
+                  <a:srgbClr val="AD4426"/>
+                </a:solidFill>
+                <a:latin typeface="Calibri" pitchFamily="34" charset="0"/>
+                <a:ea typeface="Calibri" pitchFamily="34" charset="-122"/>
+                <a:cs typeface="Calibri" pitchFamily="34" charset="-120"/>
+              </a:rPr>
+              <a:t>✗ </a:t>
+            </a:r>
+            <a:pPr indent="0" marL="0">
+              <a:buNone/>
+            </a:pPr>
+            <a:r>
+              <a:rPr lang="en-US" sz="1150" b="1" dirty="0">
+                <a:solidFill>
+                  <a:srgbClr val="AD4426"/>
+                </a:solidFill>
+                <a:latin typeface="Calibri" pitchFamily="34" charset="0"/>
+                <a:ea typeface="Calibri" pitchFamily="34" charset="-122"/>
+                <a:cs typeface="Calibri" pitchFamily="34" charset="-120"/>
+              </a:rPr>
+              <a:t>Die Verfassung bleibt – die Ämter bekommen seine Anhänger.</a:t>
+            </a:r>
+            <a:endParaRPr lang="en-US" sz="1150" dirty="0"/>
+          </a:p>
+        </p:txBody>
+      </p:sp>
+      <p:sp>
+        <p:nvSpPr>
+          <p:cNvPr id="39" name="Shape 37"/>
+          <p:cNvSpPr/>
+          <p:nvPr/>
+        </p:nvSpPr>
+        <p:spPr>
+          <a:xfrm>
+            <a:off x="457200" y="4389120"/>
+            <a:ext cx="8229600" cy="329184"/>
+          </a:xfrm>
+          <a:prstGeom prst="roundRect">
+            <a:avLst>
+              <a:gd name="adj" fmla="val 22222"/>
+            </a:avLst>
+          </a:prstGeom>
+          <a:solidFill>
+            <a:srgbClr val="2B2318"/>
+          </a:solidFill>
+          <a:ln w="12700">
+            <a:solidFill>
+              <a:srgbClr val="2B2318"/>
+            </a:solidFill>
+            <a:prstDash val="solid"/>
+          </a:ln>
+        </p:spPr>
+      </p:sp>
+      <p:sp>
+        <p:nvSpPr>
+          <p:cNvPr id="40" name="Text 38"/>
+          <p:cNvSpPr txBox="1"/>
+          <p:nvPr/>
+        </p:nvSpPr>
+        <p:spPr>
+          <a:xfrm>
+            <a:off x="594360" y="4389120"/>
+            <a:ext cx="7955280" cy="329184"/>
+          </a:xfrm>
+          <a:prstGeom prst="rect">
+            <a:avLst/>
+          </a:prstGeom>
+          <a:noFill/>
+          <a:ln/>
+        </p:spPr>
+        <p:txBody>
+          <a:bodyPr wrap="square" lIns="0" tIns="0" rIns="0" bIns="0" rtlCol="0" anchor="ctr"/>
+          <a:lstStyle/>
+          <a:p>
+            <a:pPr indent="0" marL="0">
+              <a:buNone/>
+            </a:pPr>
+            <a:r>
+              <a:rPr lang="en-US" sz="1150" b="1" dirty="0">
+                <a:solidFill>
+                  <a:srgbClr val="D9A441"/>
+                </a:solidFill>
+                <a:latin typeface="Calibri" pitchFamily="34" charset="0"/>
+                <a:ea typeface="Calibri" pitchFamily="34" charset="-122"/>
+                <a:cs typeface="Calibri" pitchFamily="34" charset="-120"/>
+              </a:rPr>
+              <a:t>Peisistratos – Wegbereiter der Demokratie? Ja, ungewollt. Aber: Der Adel bestimmt weiter über seine Anhänger.</a:t>
+            </a:r>
+            <a:endParaRPr lang="en-US" sz="1150" dirty="0"/>
           </a:p>
         </p:txBody>
       </p:sp>

</xml_diff>

<commit_message>
Kleisthenes: Übersetzungen der Herrschaftsformen in der Fehler-Übersicht
Co-Authored-By: Claude Opus 5.5 <noreply@anthropic.com>
Claude-Session: https://claude.ai/code/session_013iN4Tiarea1J9YUJHZ9iqC
</commit_message>
<xml_diff>
--- a/Geschichte_11/Stunde_Kleisthenes/Folien_Kleisthenes.pptx
+++ b/Geschichte_11/Stunde_Kleisthenes/Folien_Kleisthenes.pptx
@@ -8793,7 +8793,7 @@
         <p:spPr>
           <a:xfrm>
             <a:off x="457200" y="1097280"/>
-            <a:ext cx="914400" cy="274320"/>
+            <a:ext cx="822960" cy="274320"/>
           </a:xfrm>
           <a:prstGeom prst="roundRect">
             <a:avLst>
@@ -8835,8 +8835,8 @@
         </p:nvSpPr>
         <p:spPr>
           <a:xfrm>
-            <a:off x="1417320" y="1097280"/>
-            <a:ext cx="1234440" cy="274320"/>
+            <a:off x="1325880" y="1097280"/>
+            <a:ext cx="1645920" cy="274320"/>
           </a:xfrm>
           <a:prstGeom prst="roundRect">
             <a:avLst>
@@ -8864,7 +8864,7 @@
                 <a:ea typeface="Calibri" pitchFamily="34" charset="-122"/>
                 <a:cs typeface="Calibri" pitchFamily="34" charset="-120"/>
               </a:rPr>
-              <a:t>Herrschaftsform</a:t>
+              <a:t>Herrschaftsform (griech.)</a:t>
             </a:r>
             <a:endParaRPr lang="en-US" sz="1150" dirty="0"/>
           </a:p>
@@ -8878,8 +8878,8 @@
         </p:nvSpPr>
         <p:spPr>
           <a:xfrm>
-            <a:off x="2697480" y="1097280"/>
-            <a:ext cx="1325880" cy="274320"/>
+            <a:off x="3017520" y="1097280"/>
+            <a:ext cx="1143000" cy="274320"/>
           </a:xfrm>
           <a:prstGeom prst="roundRect">
             <a:avLst>
@@ -8921,8 +8921,8 @@
         </p:nvSpPr>
         <p:spPr>
           <a:xfrm>
-            <a:off x="4069080" y="1097280"/>
-            <a:ext cx="4617720" cy="274320"/>
+            <a:off x="4206240" y="1097280"/>
+            <a:ext cx="4480560" cy="274320"/>
           </a:xfrm>
           <a:prstGeom prst="roundRect">
             <a:avLst>
@@ -8992,7 +8992,7 @@
         <p:spPr>
           <a:xfrm>
             <a:off x="502920" y="1426464"/>
-            <a:ext cx="914400" cy="694944"/>
+            <a:ext cx="822960" cy="694944"/>
           </a:xfrm>
           <a:prstGeom prst="rect">
             <a:avLst/>
@@ -9030,8 +9030,8 @@
         </p:nvSpPr>
         <p:spPr>
           <a:xfrm>
-            <a:off x="1417320" y="1426464"/>
-            <a:ext cx="1234440" cy="694944"/>
+            <a:off x="1325880" y="1426464"/>
+            <a:ext cx="1645920" cy="694944"/>
           </a:xfrm>
           <a:prstGeom prst="rect">
             <a:avLst/>
@@ -9055,7 +9055,22 @@
                 <a:ea typeface="Calibri" pitchFamily="34" charset="-122"/>
                 <a:cs typeface="Calibri" pitchFamily="34" charset="-120"/>
               </a:rPr>
-              <a:t>Aristokratie</a:t>
+              <a:t>Aristokratie
+</a:t>
+            </a:r>
+            <a:pPr indent="0" marL="0">
+              <a:buNone/>
+            </a:pPr>
+            <a:r>
+              <a:rPr lang="en-US" sz="950" i="1" dirty="0">
+                <a:solidFill>
+                  <a:srgbClr val="5A5044"/>
+                </a:solidFill>
+                <a:latin typeface="Calibri" pitchFamily="34" charset="0"/>
+                <a:ea typeface="Calibri" pitchFamily="34" charset="-122"/>
+                <a:cs typeface="Calibri" pitchFamily="34" charset="-120"/>
+              </a:rPr>
+              <a:t>aristos = der Beste</a:t>
             </a:r>
             <a:endParaRPr lang="en-US" sz="1250" dirty="0"/>
           </a:p>
@@ -9069,8 +9084,8 @@
         </p:nvSpPr>
         <p:spPr>
           <a:xfrm>
-            <a:off x="2697480" y="1426464"/>
-            <a:ext cx="1325880" cy="694944"/>
+            <a:off x="3017520" y="1426464"/>
+            <a:ext cx="1143000" cy="694944"/>
           </a:xfrm>
           <a:prstGeom prst="rect">
             <a:avLst/>
@@ -9108,8 +9123,8 @@
         </p:nvSpPr>
         <p:spPr>
           <a:xfrm>
-            <a:off x="4069080" y="1453896"/>
-            <a:ext cx="4617720" cy="329184"/>
+            <a:off x="4206240" y="1453896"/>
+            <a:ext cx="4480560" cy="329184"/>
           </a:xfrm>
           <a:prstGeom prst="rect">
             <a:avLst/>
@@ -9147,8 +9162,8 @@
         </p:nvSpPr>
         <p:spPr>
           <a:xfrm>
-            <a:off x="4069080" y="1783080"/>
-            <a:ext cx="4617720" cy="329184"/>
+            <a:off x="4206240" y="1783080"/>
+            <a:ext cx="4480560" cy="329184"/>
           </a:xfrm>
           <a:prstGeom prst="rect">
             <a:avLst/>
@@ -9214,7 +9229,7 @@
         <p:spPr>
           <a:xfrm>
             <a:off x="502920" y="2157984"/>
-            <a:ext cx="914400" cy="694944"/>
+            <a:ext cx="822960" cy="694944"/>
           </a:xfrm>
           <a:prstGeom prst="rect">
             <a:avLst/>
@@ -9252,8 +9267,8 @@
         </p:nvSpPr>
         <p:spPr>
           <a:xfrm>
-            <a:off x="1417320" y="2157984"/>
-            <a:ext cx="1234440" cy="694944"/>
+            <a:off x="1325880" y="2157984"/>
+            <a:ext cx="1645920" cy="694944"/>
           </a:xfrm>
           <a:prstGeom prst="rect">
             <a:avLst/>
@@ -9277,7 +9292,22 @@
                 <a:ea typeface="Calibri" pitchFamily="34" charset="-122"/>
                 <a:cs typeface="Calibri" pitchFamily="34" charset="-120"/>
               </a:rPr>
-              <a:t>Aristokratie</a:t>
+              <a:t>Aristokratie
+</a:t>
+            </a:r>
+            <a:pPr indent="0" marL="0">
+              <a:buNone/>
+            </a:pPr>
+            <a:r>
+              <a:rPr lang="en-US" sz="950" i="1" dirty="0">
+                <a:solidFill>
+                  <a:srgbClr val="5A5044"/>
+                </a:solidFill>
+                <a:latin typeface="Calibri" pitchFamily="34" charset="0"/>
+                <a:ea typeface="Calibri" pitchFamily="34" charset="-122"/>
+                <a:cs typeface="Calibri" pitchFamily="34" charset="-120"/>
+              </a:rPr>
+              <a:t>aristos = der Beste</a:t>
             </a:r>
             <a:endParaRPr lang="en-US" sz="1250" dirty="0"/>
           </a:p>
@@ -9291,8 +9321,8 @@
         </p:nvSpPr>
         <p:spPr>
           <a:xfrm>
-            <a:off x="2697480" y="2157984"/>
-            <a:ext cx="1325880" cy="694944"/>
+            <a:off x="3017520" y="2157984"/>
+            <a:ext cx="1143000" cy="694944"/>
           </a:xfrm>
           <a:prstGeom prst="rect">
             <a:avLst/>
@@ -9330,8 +9360,8 @@
         </p:nvSpPr>
         <p:spPr>
           <a:xfrm>
-            <a:off x="4069080" y="2185416"/>
-            <a:ext cx="4617720" cy="329184"/>
+            <a:off x="4206240" y="2185416"/>
+            <a:ext cx="4480560" cy="329184"/>
           </a:xfrm>
           <a:prstGeom prst="rect">
             <a:avLst/>
@@ -9369,8 +9399,8 @@
         </p:nvSpPr>
         <p:spPr>
           <a:xfrm>
-            <a:off x="4069080" y="2514600"/>
-            <a:ext cx="4617720" cy="329184"/>
+            <a:off x="4206240" y="2514600"/>
+            <a:ext cx="4480560" cy="329184"/>
           </a:xfrm>
           <a:prstGeom prst="rect">
             <a:avLst/>
@@ -9436,7 +9466,7 @@
         <p:spPr>
           <a:xfrm>
             <a:off x="502920" y="2889504"/>
-            <a:ext cx="914400" cy="694944"/>
+            <a:ext cx="822960" cy="694944"/>
           </a:xfrm>
           <a:prstGeom prst="rect">
             <a:avLst/>
@@ -9474,8 +9504,8 @@
         </p:nvSpPr>
         <p:spPr>
           <a:xfrm>
-            <a:off x="1417320" y="2889504"/>
-            <a:ext cx="1234440" cy="694944"/>
+            <a:off x="1325880" y="2889504"/>
+            <a:ext cx="1645920" cy="694944"/>
           </a:xfrm>
           <a:prstGeom prst="rect">
             <a:avLst/>
@@ -9499,7 +9529,22 @@
                 <a:ea typeface="Calibri" pitchFamily="34" charset="-122"/>
                 <a:cs typeface="Calibri" pitchFamily="34" charset="-120"/>
               </a:rPr>
-              <a:t>Timokratie</a:t>
+              <a:t>Timokratie
+</a:t>
+            </a:r>
+            <a:pPr indent="0" marL="0">
+              <a:buNone/>
+            </a:pPr>
+            <a:r>
+              <a:rPr lang="en-US" sz="950" i="1" dirty="0">
+                <a:solidFill>
+                  <a:srgbClr val="5A5044"/>
+                </a:solidFill>
+                <a:latin typeface="Calibri" pitchFamily="34" charset="0"/>
+                <a:ea typeface="Calibri" pitchFamily="34" charset="-122"/>
+                <a:cs typeface="Calibri" pitchFamily="34" charset="-120"/>
+              </a:rPr>
+              <a:t>timē = Wert, Schätzung</a:t>
             </a:r>
             <a:endParaRPr lang="en-US" sz="1250" dirty="0"/>
           </a:p>
@@ -9513,8 +9558,8 @@
         </p:nvSpPr>
         <p:spPr>
           <a:xfrm>
-            <a:off x="2697480" y="2889504"/>
-            <a:ext cx="1325880" cy="694944"/>
+            <a:off x="3017520" y="2889504"/>
+            <a:ext cx="1143000" cy="694944"/>
           </a:xfrm>
           <a:prstGeom prst="rect">
             <a:avLst/>
@@ -9552,8 +9597,8 @@
         </p:nvSpPr>
         <p:spPr>
           <a:xfrm>
-            <a:off x="4069080" y="2916936"/>
-            <a:ext cx="4617720" cy="329184"/>
+            <a:off x="4206240" y="2916936"/>
+            <a:ext cx="4480560" cy="329184"/>
           </a:xfrm>
           <a:prstGeom prst="rect">
             <a:avLst/>
@@ -9591,8 +9636,8 @@
         </p:nvSpPr>
         <p:spPr>
           <a:xfrm>
-            <a:off x="4069080" y="3246120"/>
-            <a:ext cx="4617720" cy="329184"/>
+            <a:off x="4206240" y="3246120"/>
+            <a:ext cx="4480560" cy="329184"/>
           </a:xfrm>
           <a:prstGeom prst="rect">
             <a:avLst/>
@@ -9658,7 +9703,7 @@
         <p:spPr>
           <a:xfrm>
             <a:off x="502920" y="3621024"/>
-            <a:ext cx="914400" cy="694944"/>
+            <a:ext cx="822960" cy="694944"/>
           </a:xfrm>
           <a:prstGeom prst="rect">
             <a:avLst/>
@@ -9696,8 +9741,8 @@
         </p:nvSpPr>
         <p:spPr>
           <a:xfrm>
-            <a:off x="1417320" y="3621024"/>
-            <a:ext cx="1234440" cy="694944"/>
+            <a:off x="1325880" y="3621024"/>
+            <a:ext cx="1645920" cy="694944"/>
           </a:xfrm>
           <a:prstGeom prst="rect">
             <a:avLst/>
@@ -9721,7 +9766,22 @@
                 <a:ea typeface="Calibri" pitchFamily="34" charset="-122"/>
                 <a:cs typeface="Calibri" pitchFamily="34" charset="-120"/>
               </a:rPr>
-              <a:t>Tyrannis</a:t>
+              <a:t>Tyrannis
+</a:t>
+            </a:r>
+            <a:pPr indent="0" marL="0">
+              <a:buNone/>
+            </a:pPr>
+            <a:r>
+              <a:rPr lang="en-US" sz="950" i="1" dirty="0">
+                <a:solidFill>
+                  <a:srgbClr val="5A5044"/>
+                </a:solidFill>
+                <a:latin typeface="Calibri" pitchFamily="34" charset="0"/>
+                <a:ea typeface="Calibri" pitchFamily="34" charset="-122"/>
+                <a:cs typeface="Calibri" pitchFamily="34" charset="-120"/>
+              </a:rPr>
+              <a:t>tyrannos = Alleinherrscher</a:t>
             </a:r>
             <a:endParaRPr lang="en-US" sz="1250" dirty="0"/>
           </a:p>
@@ -9735,8 +9795,8 @@
         </p:nvSpPr>
         <p:spPr>
           <a:xfrm>
-            <a:off x="2697480" y="3621024"/>
-            <a:ext cx="1325880" cy="694944"/>
+            <a:off x="3017520" y="3621024"/>
+            <a:ext cx="1143000" cy="694944"/>
           </a:xfrm>
           <a:prstGeom prst="rect">
             <a:avLst/>
@@ -9774,8 +9834,8 @@
         </p:nvSpPr>
         <p:spPr>
           <a:xfrm>
-            <a:off x="4069080" y="3648456"/>
-            <a:ext cx="4617720" cy="329184"/>
+            <a:off x="4206240" y="3648456"/>
+            <a:ext cx="4480560" cy="329184"/>
           </a:xfrm>
           <a:prstGeom prst="rect">
             <a:avLst/>
@@ -9813,8 +9873,8 @@
         </p:nvSpPr>
         <p:spPr>
           <a:xfrm>
-            <a:off x="4069080" y="3977640"/>
-            <a:ext cx="4617720" cy="329184"/>
+            <a:off x="4206240" y="3977640"/>
+            <a:ext cx="4480560" cy="329184"/>
           </a:xfrm>
           <a:prstGeom prst="rect">
             <a:avLst/>
@@ -9904,7 +9964,7 @@
                 <a:ea typeface="Calibri" pitchFamily="34" charset="-122"/>
                 <a:cs typeface="Calibri" pitchFamily="34" charset="-120"/>
               </a:rPr>
-              <a:t>Finde die 6 Fehler und berichtige sie im Heft. Dann vergleiche mit deinem Nachbarn.</a:t>
+              <a:t>Finde die 6 Fehler und berichtige sie im Heft. Dann vergleiche mit deinem Nachbarn.   (-kratie: kratein = herrschen)</a:t>
             </a:r>
             <a:endParaRPr lang="en-US" sz="1150" dirty="0"/>
           </a:p>
@@ -10326,7 +10386,7 @@
         <p:spPr>
           <a:xfrm>
             <a:off x="457200" y="1097280"/>
-            <a:ext cx="914400" cy="274320"/>
+            <a:ext cx="822960" cy="274320"/>
           </a:xfrm>
           <a:prstGeom prst="roundRect">
             <a:avLst>
@@ -10368,8 +10428,8 @@
         </p:nvSpPr>
         <p:spPr>
           <a:xfrm>
-            <a:off x="1417320" y="1097280"/>
-            <a:ext cx="1234440" cy="274320"/>
+            <a:off x="1325880" y="1097280"/>
+            <a:ext cx="1645920" cy="274320"/>
           </a:xfrm>
           <a:prstGeom prst="roundRect">
             <a:avLst>
@@ -10397,7 +10457,7 @@
                 <a:ea typeface="Calibri" pitchFamily="34" charset="-122"/>
                 <a:cs typeface="Calibri" pitchFamily="34" charset="-120"/>
               </a:rPr>
-              <a:t>Herrschaftsform</a:t>
+              <a:t>Herrschaftsform (griech.)</a:t>
             </a:r>
             <a:endParaRPr lang="en-US" sz="1150" dirty="0"/>
           </a:p>
@@ -10411,8 +10471,8 @@
         </p:nvSpPr>
         <p:spPr>
           <a:xfrm>
-            <a:off x="2697480" y="1097280"/>
-            <a:ext cx="1325880" cy="274320"/>
+            <a:off x="3017520" y="1097280"/>
+            <a:ext cx="1143000" cy="274320"/>
           </a:xfrm>
           <a:prstGeom prst="roundRect">
             <a:avLst>
@@ -10454,8 +10514,8 @@
         </p:nvSpPr>
         <p:spPr>
           <a:xfrm>
-            <a:off x="4069080" y="1097280"/>
-            <a:ext cx="4617720" cy="274320"/>
+            <a:off x="4206240" y="1097280"/>
+            <a:ext cx="4480560" cy="274320"/>
           </a:xfrm>
           <a:prstGeom prst="roundRect">
             <a:avLst>
@@ -10525,7 +10585,7 @@
         <p:spPr>
           <a:xfrm>
             <a:off x="502920" y="1426464"/>
-            <a:ext cx="914400" cy="694944"/>
+            <a:ext cx="822960" cy="694944"/>
           </a:xfrm>
           <a:prstGeom prst="rect">
             <a:avLst/>
@@ -10563,8 +10623,8 @@
         </p:nvSpPr>
         <p:spPr>
           <a:xfrm>
-            <a:off x="1417320" y="1426464"/>
-            <a:ext cx="1234440" cy="694944"/>
+            <a:off x="1325880" y="1426464"/>
+            <a:ext cx="1645920" cy="694944"/>
           </a:xfrm>
           <a:prstGeom prst="rect">
             <a:avLst/>
@@ -10588,7 +10648,22 @@
                 <a:ea typeface="Calibri" pitchFamily="34" charset="-122"/>
                 <a:cs typeface="Calibri" pitchFamily="34" charset="-120"/>
               </a:rPr>
-              <a:t>Aristokratie</a:t>
+              <a:t>Aristokratie
+</a:t>
+            </a:r>
+            <a:pPr indent="0" marL="0">
+              <a:buNone/>
+            </a:pPr>
+            <a:r>
+              <a:rPr lang="en-US" sz="950" i="1" dirty="0">
+                <a:solidFill>
+                  <a:srgbClr val="5A5044"/>
+                </a:solidFill>
+                <a:latin typeface="Calibri" pitchFamily="34" charset="0"/>
+                <a:ea typeface="Calibri" pitchFamily="34" charset="-122"/>
+                <a:cs typeface="Calibri" pitchFamily="34" charset="-120"/>
+              </a:rPr>
+              <a:t>aristos = der Beste</a:t>
             </a:r>
             <a:endParaRPr lang="en-US" sz="1250" dirty="0"/>
           </a:p>
@@ -10602,8 +10677,8 @@
         </p:nvSpPr>
         <p:spPr>
           <a:xfrm>
-            <a:off x="2697480" y="1426464"/>
-            <a:ext cx="1325880" cy="694944"/>
+            <a:off x="3017520" y="1426464"/>
+            <a:ext cx="1143000" cy="694944"/>
           </a:xfrm>
           <a:prstGeom prst="rect">
             <a:avLst/>
@@ -10641,8 +10716,8 @@
         </p:nvSpPr>
         <p:spPr>
           <a:xfrm>
-            <a:off x="4069080" y="1453896"/>
-            <a:ext cx="4617720" cy="329184"/>
+            <a:off x="4206240" y="1453896"/>
+            <a:ext cx="4480560" cy="329184"/>
           </a:xfrm>
           <a:prstGeom prst="rect">
             <a:avLst/>
@@ -10680,8 +10755,8 @@
         </p:nvSpPr>
         <p:spPr>
           <a:xfrm>
-            <a:off x="4069080" y="1783080"/>
-            <a:ext cx="4617720" cy="329184"/>
+            <a:off x="4206240" y="1783080"/>
+            <a:ext cx="4480560" cy="329184"/>
           </a:xfrm>
           <a:prstGeom prst="rect">
             <a:avLst/>
@@ -10761,7 +10836,7 @@
         <p:spPr>
           <a:xfrm>
             <a:off x="502920" y="2157984"/>
-            <a:ext cx="914400" cy="694944"/>
+            <a:ext cx="822960" cy="694944"/>
           </a:xfrm>
           <a:prstGeom prst="rect">
             <a:avLst/>
@@ -10799,8 +10874,8 @@
         </p:nvSpPr>
         <p:spPr>
           <a:xfrm>
-            <a:off x="1417320" y="2157984"/>
-            <a:ext cx="1234440" cy="694944"/>
+            <a:off x="1325880" y="2157984"/>
+            <a:ext cx="1645920" cy="694944"/>
           </a:xfrm>
           <a:prstGeom prst="rect">
             <a:avLst/>
@@ -10824,7 +10899,22 @@
                 <a:ea typeface="Calibri" pitchFamily="34" charset="-122"/>
                 <a:cs typeface="Calibri" pitchFamily="34" charset="-120"/>
               </a:rPr>
-              <a:t>Aristokratie</a:t>
+              <a:t>Aristokratie
+</a:t>
+            </a:r>
+            <a:pPr indent="0" marL="0">
+              <a:buNone/>
+            </a:pPr>
+            <a:r>
+              <a:rPr lang="en-US" sz="950" i="1" dirty="0">
+                <a:solidFill>
+                  <a:srgbClr val="5A5044"/>
+                </a:solidFill>
+                <a:latin typeface="Calibri" pitchFamily="34" charset="0"/>
+                <a:ea typeface="Calibri" pitchFamily="34" charset="-122"/>
+                <a:cs typeface="Calibri" pitchFamily="34" charset="-120"/>
+              </a:rPr>
+              <a:t>aristos = der Beste</a:t>
             </a:r>
             <a:endParaRPr lang="en-US" sz="1250" dirty="0"/>
           </a:p>
@@ -10838,8 +10928,8 @@
         </p:nvSpPr>
         <p:spPr>
           <a:xfrm>
-            <a:off x="2697480" y="2157984"/>
-            <a:ext cx="1325880" cy="694944"/>
+            <a:off x="3017520" y="2157984"/>
+            <a:ext cx="1143000" cy="694944"/>
           </a:xfrm>
           <a:prstGeom prst="rect">
             <a:avLst/>
@@ -10877,8 +10967,8 @@
         </p:nvSpPr>
         <p:spPr>
           <a:xfrm>
-            <a:off x="4069080" y="2185416"/>
-            <a:ext cx="4617720" cy="329184"/>
+            <a:off x="4206240" y="2185416"/>
+            <a:ext cx="4480560" cy="329184"/>
           </a:xfrm>
           <a:prstGeom prst="rect">
             <a:avLst/>
@@ -10916,8 +11006,8 @@
         </p:nvSpPr>
         <p:spPr>
           <a:xfrm>
-            <a:off x="4069080" y="2514600"/>
-            <a:ext cx="4617720" cy="329184"/>
+            <a:off x="4206240" y="2514600"/>
+            <a:ext cx="4480560" cy="329184"/>
           </a:xfrm>
           <a:prstGeom prst="rect">
             <a:avLst/>
@@ -10997,7 +11087,7 @@
         <p:spPr>
           <a:xfrm>
             <a:off x="502920" y="2889504"/>
-            <a:ext cx="914400" cy="694944"/>
+            <a:ext cx="822960" cy="694944"/>
           </a:xfrm>
           <a:prstGeom prst="rect">
             <a:avLst/>
@@ -11035,8 +11125,8 @@
         </p:nvSpPr>
         <p:spPr>
           <a:xfrm>
-            <a:off x="1417320" y="2889504"/>
-            <a:ext cx="1234440" cy="694944"/>
+            <a:off x="1325880" y="2889504"/>
+            <a:ext cx="1645920" cy="694944"/>
           </a:xfrm>
           <a:prstGeom prst="rect">
             <a:avLst/>
@@ -11060,7 +11150,22 @@
                 <a:ea typeface="Calibri" pitchFamily="34" charset="-122"/>
                 <a:cs typeface="Calibri" pitchFamily="34" charset="-120"/>
               </a:rPr>
-              <a:t>Timokratie</a:t>
+              <a:t>Timokratie
+</a:t>
+            </a:r>
+            <a:pPr indent="0" marL="0">
+              <a:buNone/>
+            </a:pPr>
+            <a:r>
+              <a:rPr lang="en-US" sz="950" i="1" dirty="0">
+                <a:solidFill>
+                  <a:srgbClr val="5A5044"/>
+                </a:solidFill>
+                <a:latin typeface="Calibri" pitchFamily="34" charset="0"/>
+                <a:ea typeface="Calibri" pitchFamily="34" charset="-122"/>
+                <a:cs typeface="Calibri" pitchFamily="34" charset="-120"/>
+              </a:rPr>
+              <a:t>timē = Wert, Schätzung</a:t>
             </a:r>
             <a:endParaRPr lang="en-US" sz="1250" dirty="0"/>
           </a:p>
@@ -11074,8 +11179,8 @@
         </p:nvSpPr>
         <p:spPr>
           <a:xfrm>
-            <a:off x="2697480" y="2889504"/>
-            <a:ext cx="1325880" cy="694944"/>
+            <a:off x="3017520" y="2889504"/>
+            <a:ext cx="1143000" cy="694944"/>
           </a:xfrm>
           <a:prstGeom prst="rect">
             <a:avLst/>
@@ -11113,8 +11218,8 @@
         </p:nvSpPr>
         <p:spPr>
           <a:xfrm>
-            <a:off x="4069080" y="2916936"/>
-            <a:ext cx="4617720" cy="329184"/>
+            <a:off x="4206240" y="2916936"/>
+            <a:ext cx="4480560" cy="329184"/>
           </a:xfrm>
           <a:prstGeom prst="rect">
             <a:avLst/>
@@ -11166,8 +11271,8 @@
         </p:nvSpPr>
         <p:spPr>
           <a:xfrm>
-            <a:off x="4069080" y="3246120"/>
-            <a:ext cx="4617720" cy="329184"/>
+            <a:off x="4206240" y="3246120"/>
+            <a:ext cx="4480560" cy="329184"/>
           </a:xfrm>
           <a:prstGeom prst="rect">
             <a:avLst/>
@@ -11247,7 +11352,7 @@
         <p:spPr>
           <a:xfrm>
             <a:off x="502920" y="3621024"/>
-            <a:ext cx="914400" cy="694944"/>
+            <a:ext cx="822960" cy="694944"/>
           </a:xfrm>
           <a:prstGeom prst="rect">
             <a:avLst/>
@@ -11285,8 +11390,8 @@
         </p:nvSpPr>
         <p:spPr>
           <a:xfrm>
-            <a:off x="1417320" y="3621024"/>
-            <a:ext cx="1234440" cy="694944"/>
+            <a:off x="1325880" y="3621024"/>
+            <a:ext cx="1645920" cy="694944"/>
           </a:xfrm>
           <a:prstGeom prst="rect">
             <a:avLst/>
@@ -11310,7 +11415,22 @@
                 <a:ea typeface="Calibri" pitchFamily="34" charset="-122"/>
                 <a:cs typeface="Calibri" pitchFamily="34" charset="-120"/>
               </a:rPr>
-              <a:t>Tyrannis</a:t>
+              <a:t>Tyrannis
+</a:t>
+            </a:r>
+            <a:pPr indent="0" marL="0">
+              <a:buNone/>
+            </a:pPr>
+            <a:r>
+              <a:rPr lang="en-US" sz="950" i="1" dirty="0">
+                <a:solidFill>
+                  <a:srgbClr val="5A5044"/>
+                </a:solidFill>
+                <a:latin typeface="Calibri" pitchFamily="34" charset="0"/>
+                <a:ea typeface="Calibri" pitchFamily="34" charset="-122"/>
+                <a:cs typeface="Calibri" pitchFamily="34" charset="-120"/>
+              </a:rPr>
+              <a:t>tyrannos = Alleinherrscher</a:t>
             </a:r>
             <a:endParaRPr lang="en-US" sz="1250" dirty="0"/>
           </a:p>
@@ -11324,8 +11444,8 @@
         </p:nvSpPr>
         <p:spPr>
           <a:xfrm>
-            <a:off x="2697480" y="3621024"/>
-            <a:ext cx="1325880" cy="694944"/>
+            <a:off x="3017520" y="3621024"/>
+            <a:ext cx="1143000" cy="694944"/>
           </a:xfrm>
           <a:prstGeom prst="rect">
             <a:avLst/>
@@ -11363,8 +11483,8 @@
         </p:nvSpPr>
         <p:spPr>
           <a:xfrm>
-            <a:off x="4069080" y="3648456"/>
-            <a:ext cx="4617720" cy="329184"/>
+            <a:off x="4206240" y="3648456"/>
+            <a:ext cx="4480560" cy="329184"/>
           </a:xfrm>
           <a:prstGeom prst="rect">
             <a:avLst/>
@@ -11416,8 +11536,8 @@
         </p:nvSpPr>
         <p:spPr>
           <a:xfrm>
-            <a:off x="4069080" y="3977640"/>
-            <a:ext cx="4617720" cy="329184"/>
+            <a:off x="4206240" y="3977640"/>
+            <a:ext cx="4480560" cy="329184"/>
           </a:xfrm>
           <a:prstGeom prst="rect">
             <a:avLst/>

</xml_diff>

<commit_message>
Kleisthenes: Mystery mit 8 Textabschnitten statt 18 Schnipseln, ohne Ablenker; Folien, Hilfen und Handreichung angepasst
Co-Authored-By: Claude Opus 5.5 <noreply@anthropic.com>
Claude-Session: https://claude.ai/code/session_013iN4Tiarea1J9YUJHZ9iqC
</commit_message>
<xml_diff>
--- a/Geschichte_11/Stunde_Kleisthenes/Folien_Kleisthenes.pptx
+++ b/Geschichte_11/Stunde_Kleisthenes/Folien_Kleisthenes.pptx
@@ -1570,7 +1570,7 @@
           <a:p>
             <a:r>
               <a:rPr lang="en-US" dirty="0"/>
-              <a:t>15–29 Min. Indirekt: Die Gruppen erschließen die neuen Informationen selbst (Text in Schnipseln). Umhergehen, zuhören. Stolpersteine und Hilfen in der Handreichung. Nach 10 Min. ansagen: „Noch 4 Minuten – jetzt schreibt jeder die Antwort.“ Zwei Schnipsel helfen nicht (Oliven, Großvater) – sie dürfen aussortiert werden.</a:t>
+              <a:t>15–29 Min. Indirekt: Die Gruppen erschließen die neuen Informationen selbst (Text in acht Abschnitten). Umhergehen, zuhören. Stolpersteine und Hilfen in der Handreichung. Nach 10 Min. ansagen: „Noch 4 Minuten – jetzt schreibt jeder die Antwort.“ Acht Abschnitte, keine Ablenker.</a:t>
             </a:r>
             <a:endParaRPr lang="en-US" dirty="0"/>
           </a:p>
@@ -2639,7 +2639,7 @@
                 <a:ea typeface="Calibri" pitchFamily="34" charset="-122"/>
                 <a:cs typeface="Calibri" pitchFamily="34" charset="-120"/>
               </a:rPr>
-              <a:t>Schnipsel 2, 5, 8, 13, 18</a:t>
+              <a:t>Abschnitt 4, 6</a:t>
             </a:r>
             <a:endParaRPr lang="en-US" sz="1050" dirty="0"/>
           </a:p>
@@ -2784,7 +2784,7 @@
                 <a:ea typeface="Calibri" pitchFamily="34" charset="-122"/>
                 <a:cs typeface="Calibri" pitchFamily="34" charset="-120"/>
               </a:rPr>
-              <a:t>Schnipsel 4, 10, 16</a:t>
+              <a:t>Abschnitt 2, 8</a:t>
             </a:r>
             <a:endParaRPr lang="en-US" sz="1050" dirty="0"/>
           </a:p>
@@ -2929,7 +2929,7 @@
                 <a:ea typeface="Calibri" pitchFamily="34" charset="-122"/>
                 <a:cs typeface="Calibri" pitchFamily="34" charset="-120"/>
               </a:rPr>
-              <a:t>Schnipsel 7, 15</a:t>
+              <a:t>Abschnitt 1, 5</a:t>
             </a:r>
             <a:endParaRPr lang="en-US" sz="1050" dirty="0"/>
           </a:p>
@@ -2968,7 +2968,7 @@
                 <a:ea typeface="Calibri" pitchFamily="34" charset="-122"/>
                 <a:cs typeface="Calibri" pitchFamily="34" charset="-120"/>
               </a:rPr>
-              <a:t>Attika wird neu gegliedert: 3 Gebiete × 10 Trittyen, daraus 10 Phylen, die Stadt, Küste und Binnenland mischen.</a:t>
+              <a:t>Attika wird neu gegliedert: 3 Gebiete × 10 Trittyen, daraus 10 Phylen, die Stadt, Küste und Binnenland mischen. Bürger ist man über seinen Demos, nicht über seine Familie.</a:t>
             </a:r>
             <a:endParaRPr lang="en-US" sz="1250" dirty="0"/>
           </a:p>
@@ -3074,7 +3074,7 @@
                 <a:ea typeface="Calibri" pitchFamily="34" charset="-122"/>
                 <a:cs typeface="Calibri" pitchFamily="34" charset="-120"/>
               </a:rPr>
-              <a:t>Schnipsel 1, 6, 11, 12, 17</a:t>
+              <a:t>Abschnitt 1, 7</a:t>
             </a:r>
             <a:endParaRPr lang="en-US" sz="1050" dirty="0"/>
           </a:p>
@@ -3113,7 +3113,7 @@
                 <a:ea typeface="Calibri" pitchFamily="34" charset="-122"/>
                 <a:cs typeface="Calibri" pitchFamily="34" charset="-120"/>
               </a:rPr>
-              <a:t>Die Gefolgschaft des Adligen wird auf mehrere Phylen verteilt. Lysias sitzt, berät und kämpft mit Fremden zusammen; er gehört zu seinem Demos statt zu einer Familie.</a:t>
+              <a:t>Die Gefolgschaft des Adligen wird auf mehrere Phylen verteilt. Lysias sitzt, berät und kämpft mit Fremden zusammen.</a:t>
             </a:r>
             <a:endParaRPr lang="en-US" sz="1250" dirty="0"/>
           </a:p>
@@ -3286,7 +3286,7 @@
                 <a:ea typeface="Calibri" pitchFamily="34" charset="-122"/>
                 <a:cs typeface="Calibri" pitchFamily="34" charset="-120"/>
               </a:rPr>
-              <a:t>* Schnipsel 9: Gegen einen neuen Tyrannen hat das Volk jetzt den Ostrakismos (Scherbengericht). Unwichtig: Schnipsel 3, 14.</a:t>
+              <a:t>* Abschnitt 3: Gegen einen neuen Tyrannen hat das Volk jetzt den Ostrakismos (Scherbengericht).</a:t>
             </a:r>
             <a:endParaRPr lang="en-US" sz="1100" dirty="0"/>
           </a:p>
@@ -14238,7 +14238,7 @@
                 <a:ea typeface="Cambria" pitchFamily="34" charset="-122"/>
                 <a:cs typeface="Cambria" pitchFamily="34" charset="-120"/>
               </a:rPr>
-              <a:t>Zwei Schnipsel verbinden</a:t>
+              <a:t>Zwei Abschnitte verbinden</a:t>
             </a:r>
             <a:endParaRPr lang="en-US" sz="2600" dirty="0"/>
           </a:p>
@@ -14371,7 +14371,7 @@
                 <a:ea typeface="Cambria" pitchFamily="34" charset="-122"/>
                 <a:cs typeface="Cambria" pitchFamily="34" charset="-120"/>
               </a:rPr>
-              <a:t>13  </a:t>
+              <a:t>4  </a:t>
             </a:r>
             <a:pPr indent="0" marL="0">
               <a:buNone/>
@@ -14385,7 +14385,7 @@
                 <a:ea typeface="Calibri" pitchFamily="34" charset="-122"/>
                 <a:cs typeface="Calibri" pitchFamily="34" charset="-120"/>
               </a:rPr>
-              <a:t>Seit Solon darf jeder Bürger über 20 in der Volksversammlung abstimmen – auch ein armer Bauer wie Lysias.</a:t>
+              <a:t>Lysias und sein Nachbar: „Seit Solon darf jeder Bürger über 20 … abstimmen – auch ein armer Bauer wie er. Sein Nachbar ist ein reicher Adliger …“</a:t>
             </a:r>
             <a:endParaRPr lang="en-US" sz="1350" dirty="0"/>
           </a:p>
@@ -14475,7 +14475,7 @@
                 <a:ea typeface="Cambria" pitchFamily="34" charset="-122"/>
                 <a:cs typeface="Cambria" pitchFamily="34" charset="-120"/>
               </a:rPr>
-              <a:t>8  </a:t>
+              <a:t>6  </a:t>
             </a:r>
             <a:pPr indent="0" marL="0">
               <a:buNone/>
@@ -14489,7 +14489,7 @@
                 <a:ea typeface="Calibri" pitchFamily="34" charset="-122"/>
                 <a:cs typeface="Calibri" pitchFamily="34" charset="-120"/>
               </a:rPr>
-              <a:t>Lysias' Nachbar ist ein reicher Adliger. In schlechten Jahren hat er Lysias Saatgut geliehen …</a:t>
+              <a:t>Die alte Ordnung: „… Dort gaben die großen Adelsfamilien den Ton an: Wer zu einer Familie hielt, stimmte mit ihr …“</a:t>
             </a:r>
             <a:endParaRPr lang="en-US" sz="1350" dirty="0"/>
           </a:p>
@@ -14612,7 +14612,7 @@
                 <a:ea typeface="Calibri" pitchFamily="34" charset="-122"/>
                 <a:cs typeface="Calibri" pitchFamily="34" charset="-120"/>
               </a:rPr>
-              <a:t>„Schnipsel 13 sagt: Er hat das Recht. Schnipsel 8 sagt: Er ist abhängig. Zusammen: Er hat das Stimmrecht, aber er nutzt es nicht frei. Die beiden lege ich nebeneinander und schreibe ‚aber‘ dazwischen.“</a:t>
+              <a:t>„Abschnitt 4 sagt: Er hat das Recht. Abschnitt 6 sagt: Die Adelsfamilien bestimmen, wie man stimmt. Zusammen: Er hat das Stimmrecht, aber er nutzt es nicht frei. Die beiden lege ich nebeneinander und schreibe ‚aber‘ dazwischen.“</a:t>
             </a:r>
             <a:endParaRPr lang="en-US" sz="1400" dirty="0"/>
           </a:p>
@@ -15266,7 +15266,7 @@
                 <a:ea typeface="Calibri" pitchFamily="34" charset="-122"/>
                 <a:cs typeface="Calibri" pitchFamily="34" charset="-120"/>
               </a:rPr>
-              <a:t>Schneidet die Schnipsel aus und verteilt sie. Jeder liest seine vor.</a:t>
+              <a:t>Schneidet die acht Abschnitte aus und verteilt sie. Jeder liest seine laut vor.</a:t>
             </a:r>
             <a:endParaRPr lang="en-US" sz="1350" dirty="0"/>
           </a:p>
@@ -15346,7 +15346,7 @@
                 <a:ea typeface="Calibri" pitchFamily="34" charset="-122"/>
                 <a:cs typeface="Calibri" pitchFamily="34" charset="-120"/>
               </a:rPr>
-              <a:t>Sortiert aus: Was hilft bei der Frage – was nicht?</a:t>
+              <a:t>Klärt: Was sagt jeder Abschnitt über Lysias und seinen Nachbarn?</a:t>
             </a:r>
             <a:endParaRPr lang="en-US" sz="1350" dirty="0"/>
           </a:p>
@@ -15426,7 +15426,7 @@
                 <a:ea typeface="Calibri" pitchFamily="34" charset="-122"/>
                 <a:cs typeface="Calibri" pitchFamily="34" charset="-120"/>
               </a:rPr>
-              <a:t>Legt die Schnipsel zu einer Erklärungskette. Schreibt Pfeile oder „weil“, „deshalb“, „aber“ dazwischen.</a:t>
+              <a:t>Legt die Abschnitte zu einer Erklärungskette. Schreibt Pfeile oder „weil“, „deshalb“, „aber“ dazwischen.</a:t>
             </a:r>
             <a:endParaRPr lang="en-US" sz="1350" dirty="0"/>
           </a:p>

</xml_diff>

<commit_message>
Kleisthenes: Wortleiste mit Verbindungswörtern zum Abstreichen; Lösung mit Verbindungswörtern
Co-Authored-By: Claude Opus 5.5 <noreply@anthropic.com>
Claude-Session: https://claude.ai/code/session_013iN4Tiarea1J9YUJHZ9iqC
</commit_message>
<xml_diff>
--- a/Geschichte_11/Stunde_Kleisthenes/Folien_Kleisthenes.pptx
+++ b/Geschichte_11/Stunde_Kleisthenes/Folien_Kleisthenes.pptx
@@ -2716,6 +2716,45 @@
         </p:nvSpPr>
         <p:spPr>
           <a:xfrm>
+            <a:off x="2011680" y="1517904"/>
+            <a:ext cx="1371600" cy="182880"/>
+          </a:xfrm>
+          <a:prstGeom prst="rect">
+            <a:avLst/>
+          </a:prstGeom>
+          <a:noFill/>
+          <a:ln/>
+        </p:spPr>
+        <p:txBody>
+          <a:bodyPr wrap="square" lIns="0" tIns="0" rIns="0" bIns="0" rtlCol="0" anchor="t"/>
+          <a:lstStyle/>
+          <a:p>
+            <a:pPr indent="0" marL="0">
+              <a:buNone/>
+            </a:pPr>
+            <a:r>
+              <a:rPr lang="en-US" sz="900" b="1" i="1" dirty="0">
+                <a:solidFill>
+                  <a:srgbClr val="AD4426"/>
+                </a:solidFill>
+                <a:latin typeface="Calibri" pitchFamily="34" charset="0"/>
+                <a:ea typeface="Calibri" pitchFamily="34" charset="-122"/>
+                <a:cs typeface="Calibri" pitchFamily="34" charset="-120"/>
+              </a:rPr>
+              <a:t>aber</a:t>
+            </a:r>
+            <a:endParaRPr lang="en-US" sz="900" dirty="0"/>
+          </a:p>
+        </p:txBody>
+      </p:sp>
+      <p:sp>
+        <p:nvSpPr>
+          <p:cNvPr id="16" name="Text 14"/>
+          <p:cNvSpPr txBox="1"/>
+          <p:nvPr/>
+        </p:nvSpPr>
+        <p:spPr>
+          <a:xfrm>
             <a:off x="457200" y="1828800"/>
             <a:ext cx="1417320" cy="530352"/>
           </a:xfrm>
@@ -2753,7 +2792,7 @@
       </p:sp>
       <p:sp>
         <p:nvSpPr>
-          <p:cNvPr id="16" name="Text 14"/>
+          <p:cNvPr id="17" name="Text 15"/>
           <p:cNvSpPr txBox="1"/>
           <p:nvPr/>
         </p:nvSpPr>
@@ -2792,7 +2831,7 @@
       </p:sp>
       <p:sp>
         <p:nvSpPr>
-          <p:cNvPr id="17" name="Text 15"/>
+          <p:cNvPr id="18" name="Text 16"/>
           <p:cNvSpPr txBox="1"/>
           <p:nvPr/>
         </p:nvSpPr>
@@ -2831,7 +2870,7 @@
       </p:sp>
       <p:sp>
         <p:nvSpPr>
-          <p:cNvPr id="18" name="Shape 16"/>
+          <p:cNvPr id="19" name="Shape 17"/>
           <p:cNvSpPr/>
           <p:nvPr/>
         </p:nvSpPr>
@@ -2855,7 +2894,46 @@
       </p:sp>
       <p:sp>
         <p:nvSpPr>
-          <p:cNvPr id="19" name="Text 17"/>
+          <p:cNvPr id="20" name="Text 18"/>
+          <p:cNvSpPr txBox="1"/>
+          <p:nvPr/>
+        </p:nvSpPr>
+        <p:spPr>
+          <a:xfrm>
+            <a:off x="2011680" y="2157984"/>
+            <a:ext cx="1371600" cy="182880"/>
+          </a:xfrm>
+          <a:prstGeom prst="rect">
+            <a:avLst/>
+          </a:prstGeom>
+          <a:noFill/>
+          <a:ln/>
+        </p:spPr>
+        <p:txBody>
+          <a:bodyPr wrap="square" lIns="0" tIns="0" rIns="0" bIns="0" rtlCol="0" anchor="t"/>
+          <a:lstStyle/>
+          <a:p>
+            <a:pPr indent="0" marL="0">
+              <a:buNone/>
+            </a:pPr>
+            <a:r>
+              <a:rPr lang="en-US" sz="900" b="1" i="1" dirty="0">
+                <a:solidFill>
+                  <a:srgbClr val="AD4426"/>
+                </a:solidFill>
+                <a:latin typeface="Calibri" pitchFamily="34" charset="0"/>
+                <a:ea typeface="Calibri" pitchFamily="34" charset="-122"/>
+                <a:cs typeface="Calibri" pitchFamily="34" charset="-120"/>
+              </a:rPr>
+              <a:t>doch dann</a:t>
+            </a:r>
+            <a:endParaRPr lang="en-US" sz="900" dirty="0"/>
+          </a:p>
+        </p:txBody>
+      </p:sp>
+      <p:sp>
+        <p:nvSpPr>
+          <p:cNvPr id="21" name="Text 19"/>
           <p:cNvSpPr txBox="1"/>
           <p:nvPr/>
         </p:nvSpPr>
@@ -2898,7 +2976,7 @@
       </p:sp>
       <p:sp>
         <p:nvSpPr>
-          <p:cNvPr id="20" name="Text 18"/>
+          <p:cNvPr id="22" name="Text 20"/>
           <p:cNvSpPr txBox="1"/>
           <p:nvPr/>
         </p:nvSpPr>
@@ -2937,7 +3015,7 @@
       </p:sp>
       <p:sp>
         <p:nvSpPr>
-          <p:cNvPr id="21" name="Text 19"/>
+          <p:cNvPr id="23" name="Text 21"/>
           <p:cNvSpPr txBox="1"/>
           <p:nvPr/>
         </p:nvSpPr>
@@ -2976,7 +3054,7 @@
       </p:sp>
       <p:sp>
         <p:nvSpPr>
-          <p:cNvPr id="22" name="Shape 20"/>
+          <p:cNvPr id="24" name="Shape 22"/>
           <p:cNvSpPr/>
           <p:nvPr/>
         </p:nvSpPr>
@@ -3000,7 +3078,46 @@
       </p:sp>
       <p:sp>
         <p:nvSpPr>
-          <p:cNvPr id="23" name="Text 21"/>
+          <p:cNvPr id="25" name="Text 23"/>
+          <p:cNvSpPr txBox="1"/>
+          <p:nvPr/>
+        </p:nvSpPr>
+        <p:spPr>
+          <a:xfrm>
+            <a:off x="2011680" y="2798064"/>
+            <a:ext cx="1371600" cy="182880"/>
+          </a:xfrm>
+          <a:prstGeom prst="rect">
+            <a:avLst/>
+          </a:prstGeom>
+          <a:noFill/>
+          <a:ln/>
+        </p:spPr>
+        <p:txBody>
+          <a:bodyPr wrap="square" lIns="0" tIns="0" rIns="0" bIns="0" rtlCol="0" anchor="t"/>
+          <a:lstStyle/>
+          <a:p>
+            <a:pPr indent="0" marL="0">
+              <a:buNone/>
+            </a:pPr>
+            <a:r>
+              <a:rPr lang="en-US" sz="900" b="1" i="1" dirty="0">
+                <a:solidFill>
+                  <a:srgbClr val="AD4426"/>
+                </a:solidFill>
+                <a:latin typeface="Calibri" pitchFamily="34" charset="0"/>
+                <a:ea typeface="Calibri" pitchFamily="34" charset="-122"/>
+                <a:cs typeface="Calibri" pitchFamily="34" charset="-120"/>
+              </a:rPr>
+              <a:t>daraufhin · danach · daraus</a:t>
+            </a:r>
+            <a:endParaRPr lang="en-US" sz="900" dirty="0"/>
+          </a:p>
+        </p:txBody>
+      </p:sp>
+      <p:sp>
+        <p:nvSpPr>
+          <p:cNvPr id="26" name="Text 24"/>
           <p:cNvSpPr txBox="1"/>
           <p:nvPr/>
         </p:nvSpPr>
@@ -3043,7 +3160,7 @@
       </p:sp>
       <p:sp>
         <p:nvSpPr>
-          <p:cNvPr id="24" name="Text 22"/>
+          <p:cNvPr id="27" name="Text 25"/>
           <p:cNvSpPr txBox="1"/>
           <p:nvPr/>
         </p:nvSpPr>
@@ -3082,7 +3199,7 @@
       </p:sp>
       <p:sp>
         <p:nvSpPr>
-          <p:cNvPr id="25" name="Text 23"/>
+          <p:cNvPr id="28" name="Text 26"/>
           <p:cNvSpPr txBox="1"/>
           <p:nvPr/>
         </p:nvSpPr>
@@ -3121,7 +3238,7 @@
       </p:sp>
       <p:sp>
         <p:nvSpPr>
-          <p:cNvPr id="26" name="Shape 24"/>
+          <p:cNvPr id="29" name="Shape 27"/>
           <p:cNvSpPr/>
           <p:nvPr/>
         </p:nvSpPr>
@@ -3145,7 +3262,46 @@
       </p:sp>
       <p:sp>
         <p:nvSpPr>
-          <p:cNvPr id="27" name="Text 25"/>
+          <p:cNvPr id="30" name="Text 28"/>
+          <p:cNvSpPr txBox="1"/>
+          <p:nvPr/>
+        </p:nvSpPr>
+        <p:spPr>
+          <a:xfrm>
+            <a:off x="2011680" y="3438144"/>
+            <a:ext cx="1371600" cy="182880"/>
+          </a:xfrm>
+          <a:prstGeom prst="rect">
+            <a:avLst/>
+          </a:prstGeom>
+          <a:noFill/>
+          <a:ln/>
+        </p:spPr>
+        <p:txBody>
+          <a:bodyPr wrap="square" lIns="0" tIns="0" rIns="0" bIns="0" rtlCol="0" anchor="t"/>
+          <a:lstStyle/>
+          <a:p>
+            <a:pPr indent="0" marL="0">
+              <a:buNone/>
+            </a:pPr>
+            <a:r>
+              <a:rPr lang="en-US" sz="900" b="1" i="1" dirty="0">
+                <a:solidFill>
+                  <a:srgbClr val="AD4426"/>
+                </a:solidFill>
+                <a:latin typeface="Calibri" pitchFamily="34" charset="0"/>
+                <a:ea typeface="Calibri" pitchFamily="34" charset="-122"/>
+                <a:cs typeface="Calibri" pitchFamily="34" charset="-120"/>
+              </a:rPr>
+              <a:t>dadurch · deshalb</a:t>
+            </a:r>
+            <a:endParaRPr lang="en-US" sz="900" dirty="0"/>
+          </a:p>
+        </p:txBody>
+      </p:sp>
+      <p:sp>
+        <p:nvSpPr>
+          <p:cNvPr id="31" name="Text 29"/>
           <p:cNvSpPr txBox="1"/>
           <p:nvPr/>
         </p:nvSpPr>
@@ -3188,7 +3344,7 @@
       </p:sp>
       <p:sp>
         <p:nvSpPr>
-          <p:cNvPr id="28" name="Text 26"/>
+          <p:cNvPr id="32" name="Text 30"/>
           <p:cNvSpPr txBox="1"/>
           <p:nvPr/>
         </p:nvSpPr>
@@ -3216,7 +3372,7 @@
       </p:sp>
       <p:sp>
         <p:nvSpPr>
-          <p:cNvPr id="29" name="Text 27"/>
+          <p:cNvPr id="33" name="Text 31"/>
           <p:cNvSpPr txBox="1"/>
           <p:nvPr/>
         </p:nvSpPr>
@@ -3255,7 +3411,7 @@
       </p:sp>
       <p:sp>
         <p:nvSpPr>
-          <p:cNvPr id="30" name="Text 28"/>
+          <p:cNvPr id="34" name="Text 32"/>
           <p:cNvSpPr txBox="1"/>
           <p:nvPr/>
         </p:nvSpPr>
@@ -3294,7 +3450,7 @@
       </p:sp>
       <p:sp>
         <p:nvSpPr>
-          <p:cNvPr id="31" name="Text 29"/>
+          <p:cNvPr id="35" name="Text 33"/>
           <p:cNvSpPr txBox="1"/>
           <p:nvPr/>
         </p:nvSpPr>
@@ -15426,7 +15582,7 @@
                 <a:ea typeface="Calibri" pitchFamily="34" charset="-122"/>
                 <a:cs typeface="Calibri" pitchFamily="34" charset="-120"/>
               </a:rPr>
-              <a:t>Legt die Abschnitte zu einer Erklärungskette. Schreibt Pfeile oder „weil“, „deshalb“, „aber“ dazwischen.</a:t>
+              <a:t>Legt die Abschnitte zu einer Erklärungskette. Schreibt die Verbindungswörter von unten auf dem Blatt dazwischen und streicht sie ab.</a:t>
             </a:r>
             <a:endParaRPr lang="en-US" sz="1350" dirty="0"/>
           </a:p>

</xml_diff>

<commit_message>
Kleisthenes: Abschnitte mit Lücke am Satzanfang, Verbindungswort ergibt grammatischen Satz; Lösung, Folien, Handreichung angepasst
Co-Authored-By: Claude Opus 5.5 <noreply@anthropic.com>
Claude-Session: https://claude.ai/code/session_013iN4Tiarea1J9YUJHZ9iqC
</commit_message>
<xml_diff>
--- a/Geschichte_11/Stunde_Kleisthenes/Folien_Kleisthenes.pptx
+++ b/Geschichte_11/Stunde_Kleisthenes/Folien_Kleisthenes.pptx
@@ -3293,7 +3293,7 @@
                 <a:ea typeface="Calibri" pitchFamily="34" charset="-122"/>
                 <a:cs typeface="Calibri" pitchFamily="34" charset="-120"/>
               </a:rPr>
-              <a:t>dadurch · deshalb</a:t>
+              <a:t>dadurch</a:t>
             </a:r>
             <a:endParaRPr lang="en-US" sz="900" dirty="0"/>
           </a:p>
@@ -3417,6 +3417,45 @@
         </p:nvSpPr>
         <p:spPr>
           <a:xfrm>
+            <a:off x="2011680" y="4078224"/>
+            <a:ext cx="1371600" cy="182880"/>
+          </a:xfrm>
+          <a:prstGeom prst="rect">
+            <a:avLst/>
+          </a:prstGeom>
+          <a:noFill/>
+          <a:ln/>
+        </p:spPr>
+        <p:txBody>
+          <a:bodyPr wrap="square" lIns="0" tIns="0" rIns="0" bIns="0" rtlCol="0" anchor="t"/>
+          <a:lstStyle/>
+          <a:p>
+            <a:pPr indent="0" marL="0">
+              <a:buNone/>
+            </a:pPr>
+            <a:r>
+              <a:rPr lang="en-US" sz="900" b="1" i="1" dirty="0">
+                <a:solidFill>
+                  <a:srgbClr val="AD4426"/>
+                </a:solidFill>
+                <a:latin typeface="Calibri" pitchFamily="34" charset="0"/>
+                <a:ea typeface="Calibri" pitchFamily="34" charset="-122"/>
+                <a:cs typeface="Calibri" pitchFamily="34" charset="-120"/>
+              </a:rPr>
+              <a:t>deshalb (Antwort)</a:t>
+            </a:r>
+            <a:endParaRPr lang="en-US" sz="900" dirty="0"/>
+          </a:p>
+        </p:txBody>
+      </p:sp>
+      <p:sp>
+        <p:nvSpPr>
+          <p:cNvPr id="35" name="Text 33"/>
+          <p:cNvSpPr txBox="1"/>
+          <p:nvPr/>
+        </p:nvSpPr>
+        <p:spPr>
+          <a:xfrm>
             <a:off x="457200" y="4434840"/>
             <a:ext cx="8229600" cy="274320"/>
           </a:xfrm>
@@ -3450,7 +3489,7 @@
       </p:sp>
       <p:sp>
         <p:nvSpPr>
-          <p:cNvPr id="35" name="Text 33"/>
+          <p:cNvPr id="36" name="Text 34"/>
           <p:cNvSpPr txBox="1"/>
           <p:nvPr/>
         </p:nvSpPr>
@@ -14645,7 +14684,7 @@
                 <a:ea typeface="Calibri" pitchFamily="34" charset="-122"/>
                 <a:cs typeface="Calibri" pitchFamily="34" charset="-120"/>
               </a:rPr>
-              <a:t>Die alte Ordnung: „… Dort gaben die großen Adelsfamilien den Ton an: Wer zu einer Familie hielt, stimmte mit ihr …“</a:t>
+              <a:t>Die alte Ordnung: „________ die großen Adelsfamilien geben in den vier alten Phylen den Ton an …“</a:t>
             </a:r>
             <a:endParaRPr lang="en-US" sz="1350" dirty="0"/>
           </a:p>
@@ -14768,7 +14807,7 @@
                 <a:ea typeface="Calibri" pitchFamily="34" charset="-122"/>
                 <a:cs typeface="Calibri" pitchFamily="34" charset="-120"/>
               </a:rPr>
-              <a:t>„Abschnitt 4 sagt: Er hat das Recht. Abschnitt 6 sagt: Die Adelsfamilien bestimmen, wie man stimmt. Zusammen: Er hat das Stimmrecht, aber er nutzt es nicht frei. Die beiden lege ich nebeneinander und schreibe ‚aber‘ dazwischen.“</a:t>
+              <a:t>„Abschnitt 4 sagt: Er hat das Recht. Abschnitt 6 sagt: Die Adelsfamilien bestimmen, wie man stimmt. Das ist ein Gegensatz – also passt ‚Aber‘ in die Lücke: ‚Aber die großen Adelsfamilien geben … den Ton an.‘ Der Satz stimmt, ich streiche ‚aber‘ unten ab.“</a:t>
             </a:r>
             <a:endParaRPr lang="en-US" sz="1400" dirty="0"/>
           </a:p>
@@ -15582,7 +15621,7 @@
                 <a:ea typeface="Calibri" pitchFamily="34" charset="-122"/>
                 <a:cs typeface="Calibri" pitchFamily="34" charset="-120"/>
               </a:rPr>
-              <a:t>Legt die Abschnitte zu einer Erklärungskette. Schreibt die Verbindungswörter von unten auf dem Blatt dazwischen und streicht sie ab.</a:t>
+              <a:t>Legt die Abschnitte zu einer Erklärungskette. Schreibt die passenden Verbindungswörter (unten auf dem Blatt) in die Lücken am Anfang der Abschnitte und streicht sie ab.</a:t>
             </a:r>
             <a:endParaRPr lang="en-US" sz="1350" dirty="0"/>
           </a:p>

</xml_diff>